<commit_message>
Deck rebased on the hand-edited 14-slide version; generated slides regenerated in place; new slide on where the likelihood margin comes from (fig24); Figure 1 label 'measured'
Co-Authored-By: Claude Fable 5 <noreply@anthropic.com>
</commit_message>
<xml_diff>
--- a/pipeline/deck_base.pptx
+++ b/pipeline/deck_base.pptx
@@ -4,10 +4,18 @@
   <p:sldMasterIdLst>
     <p:sldMasterId id="2147483648" r:id="rId1"/>
   </p:sldMasterIdLst>
+  <p:notesMasterIdLst>
+    <p:notesMasterId r:id="rId16"/>
+  </p:notesMasterIdLst>
   <p:sldIdLst>
     <p:sldId id="256" r:id="rId2"/>
-    <p:sldId id="257" r:id="rId3"/>
-    <p:sldId id="258" r:id="rId4"/>
+    <p:sldId id="267" r:id="rId3"/>
+    <p:sldId id="268" r:id="rId4"/>
+    <p:sldId id="269" r:id="rId5"/>
+    <p:sldId id="257" r:id="rId6"/>
+    <p:sldId id="258" r:id="rId7"/>
+    <p:sldId id="259" r:id="rId8"/>
+    <p:sldId id="261" r:id="rId10"/>
   </p:sldIdLst>
   <p:sldSz cx="12192000" cy="6858000"/>
   <p:notesSz cx="6858000" cy="9144000"/>
@@ -123,6 +131,439 @@
     </p:ext>
   </p:extLst>
 </p:presentation>
+</file>
+
+<file path=ppt/notesMasters/notesMaster1.xml><?xml version="1.0" encoding="utf-8"?>
+<p:notesMaster xmlns:a="http://schemas.openxmlformats.org/drawingml/2006/main" xmlns:r="http://schemas.openxmlformats.org/officeDocument/2006/relationships" xmlns:p="http://schemas.openxmlformats.org/presentationml/2006/main">
+  <p:cSld>
+    <p:bg>
+      <p:bgRef idx="1001">
+        <a:schemeClr val="bg1"/>
+      </p:bgRef>
+    </p:bg>
+    <p:spTree>
+      <p:nvGrpSpPr>
+        <p:cNvPr id="1" name=""/>
+        <p:cNvGrpSpPr/>
+        <p:nvPr/>
+      </p:nvGrpSpPr>
+      <p:grpSpPr>
+        <a:xfrm>
+          <a:off x="0" y="0"/>
+          <a:ext cx="0" cy="0"/>
+          <a:chOff x="0" y="0"/>
+          <a:chExt cx="0" cy="0"/>
+        </a:xfrm>
+      </p:grpSpPr>
+      <p:sp>
+        <p:nvSpPr>
+          <p:cNvPr id="2" name="Header Placeholder 1"/>
+          <p:cNvSpPr>
+            <a:spLocks noGrp="1"/>
+          </p:cNvSpPr>
+          <p:nvPr>
+            <p:ph type="hdr" sz="quarter"/>
+          </p:nvPr>
+        </p:nvSpPr>
+        <p:spPr>
+          <a:xfrm>
+            <a:off x="0" y="0"/>
+            <a:ext cx="2971800" cy="458788"/>
+          </a:xfrm>
+          <a:prstGeom prst="rect">
+            <a:avLst/>
+          </a:prstGeom>
+        </p:spPr>
+        <p:txBody>
+          <a:bodyPr vert="horz" lIns="91440" tIns="45720" rIns="91440" bIns="45720" rtlCol="0"/>
+          <a:lstStyle>
+            <a:lvl1pPr algn="l">
+              <a:defRPr sz="1200"/>
+            </a:lvl1pPr>
+          </a:lstStyle>
+          <a:p>
+            <a:endParaRPr lang="en-US"/>
+          </a:p>
+        </p:txBody>
+      </p:sp>
+      <p:sp>
+        <p:nvSpPr>
+          <p:cNvPr id="3" name="Date Placeholder 2"/>
+          <p:cNvSpPr>
+            <a:spLocks noGrp="1"/>
+          </p:cNvSpPr>
+          <p:nvPr>
+            <p:ph type="dt" idx="1"/>
+          </p:nvPr>
+        </p:nvSpPr>
+        <p:spPr>
+          <a:xfrm>
+            <a:off x="3884613" y="0"/>
+            <a:ext cx="2971800" cy="458788"/>
+          </a:xfrm>
+          <a:prstGeom prst="rect">
+            <a:avLst/>
+          </a:prstGeom>
+        </p:spPr>
+        <p:txBody>
+          <a:bodyPr vert="horz" lIns="91440" tIns="45720" rIns="91440" bIns="45720" rtlCol="0"/>
+          <a:lstStyle>
+            <a:lvl1pPr algn="r">
+              <a:defRPr sz="1200"/>
+            </a:lvl1pPr>
+          </a:lstStyle>
+          <a:p>
+            <a:fld id="{3D556A4C-1FD7-434B-80AC-C9E232A2F4A8}" type="datetimeFigureOut">
+              <a:rPr lang="en-US" smtClean="0"/>
+              <a:t>9/4/26</a:t>
+            </a:fld>
+            <a:endParaRPr lang="en-US"/>
+          </a:p>
+        </p:txBody>
+      </p:sp>
+      <p:sp>
+        <p:nvSpPr>
+          <p:cNvPr id="4" name="Slide Image Placeholder 3"/>
+          <p:cNvSpPr>
+            <a:spLocks noGrp="1" noRot="1" noChangeAspect="1"/>
+          </p:cNvSpPr>
+          <p:nvPr>
+            <p:ph type="sldImg" idx="2"/>
+          </p:nvPr>
+        </p:nvSpPr>
+        <p:spPr>
+          <a:xfrm>
+            <a:off x="685800" y="1143000"/>
+            <a:ext cx="5486400" cy="3086100"/>
+          </a:xfrm>
+          <a:prstGeom prst="rect">
+            <a:avLst/>
+          </a:prstGeom>
+          <a:noFill/>
+          <a:ln w="12700">
+            <a:solidFill>
+              <a:prstClr val="black"/>
+            </a:solidFill>
+          </a:ln>
+        </p:spPr>
+        <p:txBody>
+          <a:bodyPr vert="horz" lIns="91440" tIns="45720" rIns="91440" bIns="45720" rtlCol="0" anchor="ctr"/>
+          <a:lstStyle/>
+          <a:p>
+            <a:endParaRPr lang="en-US"/>
+          </a:p>
+        </p:txBody>
+      </p:sp>
+      <p:sp>
+        <p:nvSpPr>
+          <p:cNvPr id="5" name="Notes Placeholder 4"/>
+          <p:cNvSpPr>
+            <a:spLocks noGrp="1"/>
+          </p:cNvSpPr>
+          <p:nvPr>
+            <p:ph type="body" sz="quarter" idx="3"/>
+          </p:nvPr>
+        </p:nvSpPr>
+        <p:spPr>
+          <a:xfrm>
+            <a:off x="685800" y="4400550"/>
+            <a:ext cx="5486400" cy="3600450"/>
+          </a:xfrm>
+          <a:prstGeom prst="rect">
+            <a:avLst/>
+          </a:prstGeom>
+        </p:spPr>
+        <p:txBody>
+          <a:bodyPr vert="horz" lIns="91440" tIns="45720" rIns="91440" bIns="45720" rtlCol="0"/>
+          <a:lstStyle/>
+          <a:p>
+            <a:pPr lvl="0"/>
+            <a:r>
+              <a:rPr lang="en-US"/>
+              <a:t>Click to edit Master text styles</a:t>
+            </a:r>
+          </a:p>
+          <a:p>
+            <a:pPr lvl="1"/>
+            <a:r>
+              <a:rPr lang="en-US"/>
+              <a:t>Second level</a:t>
+            </a:r>
+          </a:p>
+          <a:p>
+            <a:pPr lvl="2"/>
+            <a:r>
+              <a:rPr lang="en-US"/>
+              <a:t>Third level</a:t>
+            </a:r>
+          </a:p>
+          <a:p>
+            <a:pPr lvl="3"/>
+            <a:r>
+              <a:rPr lang="en-US"/>
+              <a:t>Fourth level</a:t>
+            </a:r>
+          </a:p>
+          <a:p>
+            <a:pPr lvl="4"/>
+            <a:r>
+              <a:rPr lang="en-US"/>
+              <a:t>Fifth level</a:t>
+            </a:r>
+          </a:p>
+        </p:txBody>
+      </p:sp>
+      <p:sp>
+        <p:nvSpPr>
+          <p:cNvPr id="6" name="Footer Placeholder 5"/>
+          <p:cNvSpPr>
+            <a:spLocks noGrp="1"/>
+          </p:cNvSpPr>
+          <p:nvPr>
+            <p:ph type="ftr" sz="quarter" idx="4"/>
+          </p:nvPr>
+        </p:nvSpPr>
+        <p:spPr>
+          <a:xfrm>
+            <a:off x="0" y="8685213"/>
+            <a:ext cx="2971800" cy="458787"/>
+          </a:xfrm>
+          <a:prstGeom prst="rect">
+            <a:avLst/>
+          </a:prstGeom>
+        </p:spPr>
+        <p:txBody>
+          <a:bodyPr vert="horz" lIns="91440" tIns="45720" rIns="91440" bIns="45720" rtlCol="0" anchor="b"/>
+          <a:lstStyle>
+            <a:lvl1pPr algn="l">
+              <a:defRPr sz="1200"/>
+            </a:lvl1pPr>
+          </a:lstStyle>
+          <a:p>
+            <a:endParaRPr lang="en-US"/>
+          </a:p>
+        </p:txBody>
+      </p:sp>
+      <p:sp>
+        <p:nvSpPr>
+          <p:cNvPr id="7" name="Slide Number Placeholder 6"/>
+          <p:cNvSpPr>
+            <a:spLocks noGrp="1"/>
+          </p:cNvSpPr>
+          <p:nvPr>
+            <p:ph type="sldNum" sz="quarter" idx="5"/>
+          </p:nvPr>
+        </p:nvSpPr>
+        <p:spPr>
+          <a:xfrm>
+            <a:off x="3884613" y="8685213"/>
+            <a:ext cx="2971800" cy="458787"/>
+          </a:xfrm>
+          <a:prstGeom prst="rect">
+            <a:avLst/>
+          </a:prstGeom>
+        </p:spPr>
+        <p:txBody>
+          <a:bodyPr vert="horz" lIns="91440" tIns="45720" rIns="91440" bIns="45720" rtlCol="0" anchor="b"/>
+          <a:lstStyle>
+            <a:lvl1pPr algn="r">
+              <a:defRPr sz="1200"/>
+            </a:lvl1pPr>
+          </a:lstStyle>
+          <a:p>
+            <a:fld id="{93A96F5B-8A98-3E49-846B-DE69B9356157}" type="slidenum">
+              <a:rPr lang="en-US" smtClean="0"/>
+              <a:t>‹#›</a:t>
+            </a:fld>
+            <a:endParaRPr lang="en-US"/>
+          </a:p>
+        </p:txBody>
+      </p:sp>
+    </p:spTree>
+    <p:extLst>
+      <p:ext uri="{BB962C8B-B14F-4D97-AF65-F5344CB8AC3E}">
+        <p14:creationId xmlns:p14="http://schemas.microsoft.com/office/powerpoint/2010/main" val="1786408941"/>
+      </p:ext>
+    </p:extLst>
+  </p:cSld>
+  <p:clrMap bg1="lt1" tx1="dk1" bg2="lt2" tx2="dk2" accent1="accent1" accent2="accent2" accent3="accent3" accent4="accent4" accent5="accent5" accent6="accent6" hlink="hlink" folHlink="folHlink"/>
+  <p:notesStyle>
+    <a:lvl1pPr marL="0" algn="l" defTabSz="914400" rtl="0" eaLnBrk="1" latinLnBrk="0" hangingPunct="1">
+      <a:defRPr sz="1200" kern="1200">
+        <a:solidFill>
+          <a:schemeClr val="tx1"/>
+        </a:solidFill>
+        <a:latin typeface="+mn-lt"/>
+        <a:ea typeface="+mn-ea"/>
+        <a:cs typeface="+mn-cs"/>
+      </a:defRPr>
+    </a:lvl1pPr>
+    <a:lvl2pPr marL="457200" algn="l" defTabSz="914400" rtl="0" eaLnBrk="1" latinLnBrk="0" hangingPunct="1">
+      <a:defRPr sz="1200" kern="1200">
+        <a:solidFill>
+          <a:schemeClr val="tx1"/>
+        </a:solidFill>
+        <a:latin typeface="+mn-lt"/>
+        <a:ea typeface="+mn-ea"/>
+        <a:cs typeface="+mn-cs"/>
+      </a:defRPr>
+    </a:lvl2pPr>
+    <a:lvl3pPr marL="914400" algn="l" defTabSz="914400" rtl="0" eaLnBrk="1" latinLnBrk="0" hangingPunct="1">
+      <a:defRPr sz="1200" kern="1200">
+        <a:solidFill>
+          <a:schemeClr val="tx1"/>
+        </a:solidFill>
+        <a:latin typeface="+mn-lt"/>
+        <a:ea typeface="+mn-ea"/>
+        <a:cs typeface="+mn-cs"/>
+      </a:defRPr>
+    </a:lvl3pPr>
+    <a:lvl4pPr marL="1371600" algn="l" defTabSz="914400" rtl="0" eaLnBrk="1" latinLnBrk="0" hangingPunct="1">
+      <a:defRPr sz="1200" kern="1200">
+        <a:solidFill>
+          <a:schemeClr val="tx1"/>
+        </a:solidFill>
+        <a:latin typeface="+mn-lt"/>
+        <a:ea typeface="+mn-ea"/>
+        <a:cs typeface="+mn-cs"/>
+      </a:defRPr>
+    </a:lvl4pPr>
+    <a:lvl5pPr marL="1828800" algn="l" defTabSz="914400" rtl="0" eaLnBrk="1" latinLnBrk="0" hangingPunct="1">
+      <a:defRPr sz="1200" kern="1200">
+        <a:solidFill>
+          <a:schemeClr val="tx1"/>
+        </a:solidFill>
+        <a:latin typeface="+mn-lt"/>
+        <a:ea typeface="+mn-ea"/>
+        <a:cs typeface="+mn-cs"/>
+      </a:defRPr>
+    </a:lvl5pPr>
+    <a:lvl6pPr marL="2286000" algn="l" defTabSz="914400" rtl="0" eaLnBrk="1" latinLnBrk="0" hangingPunct="1">
+      <a:defRPr sz="1200" kern="1200">
+        <a:solidFill>
+          <a:schemeClr val="tx1"/>
+        </a:solidFill>
+        <a:latin typeface="+mn-lt"/>
+        <a:ea typeface="+mn-ea"/>
+        <a:cs typeface="+mn-cs"/>
+      </a:defRPr>
+    </a:lvl6pPr>
+    <a:lvl7pPr marL="2743200" algn="l" defTabSz="914400" rtl="0" eaLnBrk="1" latinLnBrk="0" hangingPunct="1">
+      <a:defRPr sz="1200" kern="1200">
+        <a:solidFill>
+          <a:schemeClr val="tx1"/>
+        </a:solidFill>
+        <a:latin typeface="+mn-lt"/>
+        <a:ea typeface="+mn-ea"/>
+        <a:cs typeface="+mn-cs"/>
+      </a:defRPr>
+    </a:lvl7pPr>
+    <a:lvl8pPr marL="3200400" algn="l" defTabSz="914400" rtl="0" eaLnBrk="1" latinLnBrk="0" hangingPunct="1">
+      <a:defRPr sz="1200" kern="1200">
+        <a:solidFill>
+          <a:schemeClr val="tx1"/>
+        </a:solidFill>
+        <a:latin typeface="+mn-lt"/>
+        <a:ea typeface="+mn-ea"/>
+        <a:cs typeface="+mn-cs"/>
+      </a:defRPr>
+    </a:lvl8pPr>
+    <a:lvl9pPr marL="3657600" algn="l" defTabSz="914400" rtl="0" eaLnBrk="1" latinLnBrk="0" hangingPunct="1">
+      <a:defRPr sz="1200" kern="1200">
+        <a:solidFill>
+          <a:schemeClr val="tx1"/>
+        </a:solidFill>
+        <a:latin typeface="+mn-lt"/>
+        <a:ea typeface="+mn-ea"/>
+        <a:cs typeface="+mn-cs"/>
+      </a:defRPr>
+    </a:lvl9pPr>
+  </p:notesStyle>
+</p:notesMaster>
+</file>
+
+<file path=ppt/notesSlides/notesSlide1.xml><?xml version="1.0" encoding="utf-8"?>
+<p:notes xmlns:a="http://schemas.openxmlformats.org/drawingml/2006/main" xmlns:r="http://schemas.openxmlformats.org/officeDocument/2006/relationships" xmlns:p="http://schemas.openxmlformats.org/presentationml/2006/main">
+  <p:cSld>
+    <p:spTree>
+      <p:nvGrpSpPr>
+        <p:cNvPr id="1" name=""/>
+        <p:cNvGrpSpPr/>
+        <p:nvPr/>
+      </p:nvGrpSpPr>
+      <p:grpSpPr>
+        <a:xfrm>
+          <a:off x="0" y="0"/>
+          <a:ext cx="0" cy="0"/>
+          <a:chOff x="0" y="0"/>
+          <a:chExt cx="0" cy="0"/>
+        </a:xfrm>
+      </p:grpSpPr>
+      <p:sp>
+        <p:nvSpPr>
+          <p:cNvPr id="2" name="Slide Image Placeholder 1"/>
+          <p:cNvSpPr>
+            <a:spLocks noGrp="1" noRot="1" noChangeAspect="1"/>
+          </p:cNvSpPr>
+          <p:nvPr>
+            <p:ph type="sldImg"/>
+          </p:nvPr>
+        </p:nvSpPr>
+        <p:spPr/>
+      </p:sp>
+      <p:sp>
+        <p:nvSpPr>
+          <p:cNvPr id="3" name="Notes Placeholder 2"/>
+          <p:cNvSpPr>
+            <a:spLocks noGrp="1"/>
+          </p:cNvSpPr>
+          <p:nvPr>
+            <p:ph type="body" idx="1"/>
+          </p:nvPr>
+        </p:nvSpPr>
+        <p:spPr/>
+        <p:txBody>
+          <a:bodyPr/>
+          <a:lstStyle/>
+          <a:p>
+            <a:endParaRPr lang="en-US" dirty="0"/>
+          </a:p>
+        </p:txBody>
+      </p:sp>
+      <p:sp>
+        <p:nvSpPr>
+          <p:cNvPr id="4" name="Slide Number Placeholder 3"/>
+          <p:cNvSpPr>
+            <a:spLocks noGrp="1"/>
+          </p:cNvSpPr>
+          <p:nvPr>
+            <p:ph type="sldNum" sz="quarter" idx="5"/>
+          </p:nvPr>
+        </p:nvSpPr>
+        <p:spPr/>
+        <p:txBody>
+          <a:bodyPr/>
+          <a:lstStyle/>
+          <a:p>
+            <a:fld id="{93A96F5B-8A98-3E49-846B-DE69B9356157}" type="slidenum">
+              <a:rPr lang="en-US" smtClean="0"/>
+              <a:t>7</a:t>
+            </a:fld>
+            <a:endParaRPr lang="en-US"/>
+          </a:p>
+        </p:txBody>
+      </p:sp>
+    </p:spTree>
+    <p:extLst>
+      <p:ext uri="{BB962C8B-B14F-4D97-AF65-F5344CB8AC3E}">
+        <p14:creationId xmlns:p14="http://schemas.microsoft.com/office/powerpoint/2010/main" val="3905396881"/>
+      </p:ext>
+    </p:extLst>
+  </p:cSld>
+  <p:clrMapOvr>
+    <a:masterClrMapping/>
+  </p:clrMapOvr>
+</p:notes>
 </file>
 
 <file path=ppt/slideLayouts/slideLayout1.xml><?xml version="1.0" encoding="utf-8"?>
@@ -3101,7 +3542,7 @@
         <p:spPr>
           <a:xfrm>
             <a:off x="822960" y="1737360"/>
-            <a:ext cx="10515600" cy="615553"/>
+            <a:ext cx="10515600" cy="1231106"/>
           </a:xfrm>
           <a:prstGeom prst="rect">
             <a:avLst/>
@@ -3121,7 +3562,18 @@
                 </a:solidFill>
                 <a:latin typeface="Calibri"/>
               </a:rPr>
-              <a:t>SEEM</a:t>
+              <a:t>SEEM – Symbolic Regression </a:t>
+            </a:r>
+          </a:p>
+          <a:p>
+            <a:r>
+              <a:rPr lang="en-US" sz="4000" b="1" dirty="0">
+                <a:solidFill>
+                  <a:srgbClr val="1E2761"/>
+                </a:solidFill>
+                <a:latin typeface="Calibri"/>
+              </a:rPr>
+              <a:t>for Constitutive Law Discovery</a:t>
             </a:r>
             <a:endParaRPr sz="4000" b="1" dirty="0">
               <a:solidFill>
@@ -3200,821 +3652,42 @@
           <a:chExt cx="0" cy="0"/>
         </a:xfrm>
       </p:grpSpPr>
-      <p:sp>
-        <p:nvSpPr>
-          <p:cNvPr id="2" name="TextBox 1"/>
-          <p:cNvSpPr txBox="1"/>
+      <p:pic>
+        <p:nvPicPr>
+          <p:cNvPr id="3" name="Picture 2">
+            <a:extLst>
+              <a:ext uri="{FF2B5EF4-FFF2-40B4-BE49-F238E27FC236}">
+                <a16:creationId xmlns:a16="http://schemas.microsoft.com/office/drawing/2014/main" id="{F5ACF36E-3DEB-EA88-2966-222F8DC4CE72}"/>
+              </a:ext>
+            </a:extLst>
+          </p:cNvPr>
+          <p:cNvPicPr>
+            <a:picLocks noChangeAspect="1"/>
+          </p:cNvPicPr>
           <p:nvPr/>
-        </p:nvSpPr>
+        </p:nvPicPr>
+        <p:blipFill>
+          <a:blip r:embed="rId2"/>
+          <a:stretch>
+            <a:fillRect/>
+          </a:stretch>
+        </p:blipFill>
         <p:spPr>
           <a:xfrm>
-            <a:off x="548640" y="292608"/>
-            <a:ext cx="11091672" cy="461665"/>
+            <a:off x="1852823" y="1615600"/>
+            <a:ext cx="8486353" cy="3626799"/>
           </a:xfrm>
           <a:prstGeom prst="rect">
             <a:avLst/>
           </a:prstGeom>
-          <a:noFill/>
         </p:spPr>
-        <p:txBody>
-          <a:bodyPr wrap="square" lIns="0" tIns="0" rIns="0" bIns="0">
-            <a:spAutoFit/>
-          </a:bodyPr>
-          <a:lstStyle/>
-          <a:p>
-            <a:r>
-              <a:rPr lang="en-US" sz="3000" b="1" dirty="0">
-                <a:solidFill>
-                  <a:srgbClr val="1E2761"/>
-                </a:solidFill>
-                <a:latin typeface="Calibri"/>
-              </a:rPr>
-              <a:t>Variables</a:t>
-            </a:r>
-            <a:endParaRPr sz="3000" b="1" dirty="0">
-              <a:solidFill>
-                <a:srgbClr val="1E2761"/>
-              </a:solidFill>
-              <a:latin typeface="Calibri"/>
-            </a:endParaRPr>
-          </a:p>
-        </p:txBody>
-      </p:sp>
-      <p:sp>
-        <p:nvSpPr>
-          <p:cNvPr id="3" name="TextBox 2"/>
-          <p:cNvSpPr txBox="1"/>
-          <p:nvPr/>
-        </p:nvSpPr>
-        <p:spPr>
-          <a:xfrm>
-            <a:off x="640080" y="1234440"/>
-            <a:ext cx="5394960" cy="2182649"/>
-          </a:xfrm>
-          <a:prstGeom prst="rect">
-            <a:avLst/>
-          </a:prstGeom>
-          <a:noFill/>
-        </p:spPr>
-        <p:txBody>
-          <a:bodyPr wrap="square" lIns="0" tIns="0" rIns="0" bIns="0">
-            <a:spAutoFit/>
-          </a:bodyPr>
-          <a:lstStyle/>
-          <a:p>
-            <a:pPr>
-              <a:spcAft>
-                <a:spcPts val="1100"/>
-              </a:spcAft>
-            </a:pPr>
-            <a:r>
-              <a:rPr sz="1600" b="0" dirty="0" err="1">
-                <a:solidFill>
-                  <a:srgbClr val="1E2761"/>
-                </a:solidFill>
-                <a:latin typeface="Cambria Math"/>
-              </a:rPr>
-              <a:t>γ</a:t>
-            </a:r>
-            <a:r>
-              <a:rPr sz="1600" b="0" dirty="0">
-                <a:solidFill>
-                  <a:srgbClr val="1E2761"/>
-                </a:solidFill>
-                <a:latin typeface="Cambria Math"/>
-              </a:rPr>
-              <a:t>   </a:t>
-            </a:r>
-            <a:r>
-              <a:rPr sz="1500" b="0" dirty="0">
-                <a:solidFill>
-                  <a:srgbClr val="212121"/>
-                </a:solidFill>
-                <a:latin typeface="Calibri"/>
-              </a:rPr>
-              <a:t>applied shear strain; one step is 10⁻⁵, runs go to 0.5</a:t>
-            </a:r>
-          </a:p>
-          <a:p>
-            <a:pPr>
-              <a:spcAft>
-                <a:spcPts val="1100"/>
-              </a:spcAft>
-            </a:pPr>
-            <a:r>
-              <a:rPr sz="1600" b="0" dirty="0" err="1">
-                <a:solidFill>
-                  <a:srgbClr val="1E2761"/>
-                </a:solidFill>
-                <a:latin typeface="Cambria Math"/>
-              </a:rPr>
-              <a:t>τ</a:t>
-            </a:r>
-            <a:r>
-              <a:rPr sz="1600" b="0" dirty="0">
-                <a:solidFill>
-                  <a:srgbClr val="1E2761"/>
-                </a:solidFill>
-                <a:latin typeface="Cambria Math"/>
-              </a:rPr>
-              <a:t>   </a:t>
-            </a:r>
-            <a:r>
-              <a:rPr sz="1500" b="0" dirty="0">
-                <a:solidFill>
-                  <a:srgbClr val="212121"/>
-                </a:solidFill>
-                <a:latin typeface="Calibri"/>
-              </a:rPr>
-              <a:t>shear stress (raw stress ÷ 10⁴)</a:t>
-            </a:r>
-          </a:p>
-          <a:p>
-            <a:pPr>
-              <a:spcAft>
-                <a:spcPts val="1100"/>
-              </a:spcAft>
-            </a:pPr>
-            <a:r>
-              <a:rPr sz="1600" b="0" dirty="0">
-                <a:solidFill>
-                  <a:srgbClr val="1E2761"/>
-                </a:solidFill>
-                <a:latin typeface="Cambria Math"/>
-              </a:rPr>
-              <a:t>u = pe − u₀   </a:t>
-            </a:r>
-            <a:r>
-              <a:rPr lang="en-US" sz="1500" b="0" dirty="0">
-                <a:solidFill>
-                  <a:srgbClr val="212121"/>
-                </a:solidFill>
-                <a:latin typeface="Calibri"/>
-              </a:rPr>
-              <a:t>PE/</a:t>
-            </a:r>
-            <a:r>
-              <a:rPr sz="1500" b="0" dirty="0">
-                <a:solidFill>
-                  <a:srgbClr val="212121"/>
-                </a:solidFill>
-                <a:latin typeface="Calibri"/>
-              </a:rPr>
-              <a:t>atom above the reference u₀ = −4.60752</a:t>
-            </a:r>
-          </a:p>
-          <a:p>
-            <a:pPr>
-              <a:spcAft>
-                <a:spcPts val="1100"/>
-              </a:spcAft>
-            </a:pPr>
-            <a:r>
-              <a:rPr sz="1600" b="0" dirty="0">
-                <a:solidFill>
-                  <a:srgbClr val="1E2761"/>
-                </a:solidFill>
-                <a:latin typeface="Cambria Math"/>
-              </a:rPr>
-              <a:t>(u, </a:t>
-            </a:r>
-            <a:r>
-              <a:rPr sz="1600" b="0" dirty="0" err="1">
-                <a:solidFill>
-                  <a:srgbClr val="1E2761"/>
-                </a:solidFill>
-                <a:latin typeface="Cambria Math"/>
-              </a:rPr>
-              <a:t>τ</a:t>
-            </a:r>
-            <a:r>
-              <a:rPr sz="1600" b="0" dirty="0">
-                <a:solidFill>
-                  <a:srgbClr val="1E2761"/>
-                </a:solidFill>
-                <a:latin typeface="Cambria Math"/>
-              </a:rPr>
-              <a:t>) </a:t>
-            </a:r>
-            <a:r>
-              <a:rPr sz="1500" b="0" dirty="0">
-                <a:solidFill>
-                  <a:srgbClr val="212121"/>
-                </a:solidFill>
-                <a:latin typeface="Calibri"/>
-              </a:rPr>
-              <a:t>two-coordinate state of a run; 20 × 20 grid</a:t>
-            </a:r>
-          </a:p>
-          <a:p>
-            <a:pPr>
-              <a:spcAft>
-                <a:spcPts val="1100"/>
-              </a:spcAft>
-            </a:pPr>
-            <a:r>
-              <a:rPr sz="1600" b="0" dirty="0">
-                <a:solidFill>
-                  <a:srgbClr val="1E2761"/>
-                </a:solidFill>
-                <a:latin typeface="Cambria Math"/>
-              </a:rPr>
-              <a:t>2μ(u, </a:t>
-            </a:r>
-            <a:r>
-              <a:rPr sz="1600" b="0" dirty="0" err="1">
-                <a:solidFill>
-                  <a:srgbClr val="1E2761"/>
-                </a:solidFill>
-                <a:latin typeface="Cambria Math"/>
-              </a:rPr>
-              <a:t>τ</a:t>
-            </a:r>
-            <a:r>
-              <a:rPr sz="1600" b="0" dirty="0">
-                <a:solidFill>
-                  <a:srgbClr val="1E2761"/>
-                </a:solidFill>
-                <a:latin typeface="Cambria Math"/>
-              </a:rPr>
-              <a:t>)   </a:t>
-            </a:r>
-            <a:r>
-              <a:rPr sz="1500" b="0" dirty="0">
-                <a:solidFill>
-                  <a:srgbClr val="212121"/>
-                </a:solidFill>
-                <a:latin typeface="Calibri"/>
-              </a:rPr>
-              <a:t>elastic modulus</a:t>
-            </a:r>
-          </a:p>
-          <a:p>
-            <a:pPr>
-              <a:spcAft>
-                <a:spcPts val="1100"/>
-              </a:spcAft>
-            </a:pPr>
-            <a:r>
-              <a:rPr sz="1600" b="0" dirty="0">
-                <a:solidFill>
-                  <a:srgbClr val="1E2761"/>
-                </a:solidFill>
-                <a:latin typeface="Cambria Math"/>
-              </a:rPr>
-              <a:t>s = −</a:t>
-            </a:r>
-            <a:r>
-              <a:rPr sz="1600" b="0" dirty="0" err="1">
-                <a:solidFill>
-                  <a:srgbClr val="1E2761"/>
-                </a:solidFill>
-                <a:latin typeface="Cambria Math"/>
-              </a:rPr>
-              <a:t>Δτ</a:t>
-            </a:r>
-            <a:r>
-              <a:rPr sz="1600" b="0" dirty="0">
-                <a:solidFill>
-                  <a:srgbClr val="1E2761"/>
-                </a:solidFill>
-                <a:latin typeface="Cambria Math"/>
-              </a:rPr>
-              <a:t> </a:t>
-            </a:r>
-            <a:r>
-              <a:rPr lang="en-US" sz="1600" b="0" dirty="0">
-                <a:solidFill>
-                  <a:srgbClr val="1E2761"/>
-                </a:solidFill>
-                <a:latin typeface="Cambria Math"/>
-              </a:rPr>
-              <a:t>  </a:t>
-            </a:r>
-            <a:r>
-              <a:rPr lang="en-US" sz="1500" b="0" dirty="0">
-                <a:solidFill>
-                  <a:srgbClr val="212121"/>
-                </a:solidFill>
-                <a:latin typeface="Calibri"/>
-              </a:rPr>
-              <a:t>an </a:t>
-            </a:r>
-            <a:r>
-              <a:rPr sz="1500" b="0" dirty="0">
-                <a:solidFill>
-                  <a:srgbClr val="212121"/>
-                </a:solidFill>
-                <a:latin typeface="Calibri"/>
-              </a:rPr>
-              <a:t>event: a step where the stress drops, of size s</a:t>
-            </a:r>
-          </a:p>
-        </p:txBody>
-      </p:sp>
-      <p:sp>
-        <p:nvSpPr>
-          <p:cNvPr id="4" name="TextBox 3"/>
-          <p:cNvSpPr txBox="1"/>
-          <p:nvPr/>
-        </p:nvSpPr>
-        <p:spPr>
-          <a:xfrm>
-            <a:off x="6355080" y="1234440"/>
-            <a:ext cx="5303520" cy="3172663"/>
-          </a:xfrm>
-          <a:prstGeom prst="rect">
-            <a:avLst/>
-          </a:prstGeom>
-          <a:noFill/>
-        </p:spPr>
-        <p:txBody>
-          <a:bodyPr wrap="square" lIns="0" tIns="0" rIns="0" bIns="0">
-            <a:spAutoFit/>
-          </a:bodyPr>
-          <a:lstStyle/>
-          <a:p>
-            <a:pPr>
-              <a:spcAft>
-                <a:spcPts val="1100"/>
-              </a:spcAft>
-            </a:pPr>
-            <a:r>
-              <a:rPr lang="el-GR" sz="1600" dirty="0">
-                <a:solidFill>
-                  <a:srgbClr val="1E2761"/>
-                </a:solidFill>
-                <a:latin typeface="Cambria Math"/>
-              </a:rPr>
-              <a:t>ρ(</a:t>
-            </a:r>
-            <a:r>
-              <a:rPr lang="en-US" sz="1600" dirty="0">
-                <a:solidFill>
-                  <a:srgbClr val="1E2761"/>
-                </a:solidFill>
-                <a:latin typeface="Cambria Math"/>
-              </a:rPr>
-              <a:t>s) </a:t>
-            </a:r>
-            <a:r>
-              <a:rPr lang="en-US" sz="1600" b="1" dirty="0">
-                <a:solidFill>
-                  <a:srgbClr val="212121"/>
-                </a:solidFill>
-              </a:rPr>
-              <a:t>density of events </a:t>
-            </a:r>
-            <a:r>
-              <a:rPr lang="en-US" sz="1600" dirty="0">
-                <a:solidFill>
-                  <a:srgbClr val="212121"/>
-                </a:solidFill>
-              </a:rPr>
-              <a:t>of size s</a:t>
-            </a:r>
-            <a:endParaRPr lang="en-US" sz="1600" b="0" dirty="0">
-              <a:solidFill>
-                <a:srgbClr val="1E2761"/>
-              </a:solidFill>
-              <a:latin typeface="Cambria Math"/>
-            </a:endParaRPr>
-          </a:p>
-          <a:p>
-            <a:pPr>
-              <a:spcAft>
-                <a:spcPts val="1100"/>
-              </a:spcAft>
-            </a:pPr>
-            <a:r>
-              <a:rPr sz="1600" b="0" dirty="0">
-                <a:solidFill>
-                  <a:srgbClr val="1E2761"/>
-                </a:solidFill>
-                <a:latin typeface="Cambria Math"/>
-              </a:rPr>
-              <a:t>p(u, </a:t>
-            </a:r>
-            <a:r>
-              <a:rPr sz="1600" b="0" dirty="0" err="1">
-                <a:solidFill>
-                  <a:srgbClr val="1E2761"/>
-                </a:solidFill>
-                <a:latin typeface="Cambria Math"/>
-              </a:rPr>
-              <a:t>τ</a:t>
-            </a:r>
-            <a:r>
-              <a:rPr sz="1600" b="0" dirty="0">
-                <a:solidFill>
-                  <a:srgbClr val="1E2761"/>
-                </a:solidFill>
-                <a:latin typeface="Cambria Math"/>
-              </a:rPr>
-              <a:t>) </a:t>
-            </a:r>
-            <a:r>
-              <a:rPr sz="1500" b="1" dirty="0">
-                <a:solidFill>
-                  <a:srgbClr val="212121"/>
-                </a:solidFill>
-                <a:latin typeface="Calibri"/>
-              </a:rPr>
-              <a:t>probability per step </a:t>
-            </a:r>
-            <a:r>
-              <a:rPr sz="1500" b="0" dirty="0">
-                <a:solidFill>
-                  <a:srgbClr val="212121"/>
-                </a:solidFill>
-                <a:latin typeface="Calibri"/>
-              </a:rPr>
-              <a:t>that an </a:t>
-            </a:r>
-            <a:r>
-              <a:rPr lang="en-US" sz="1500" b="0" dirty="0">
-                <a:solidFill>
-                  <a:srgbClr val="212121"/>
-                </a:solidFill>
-                <a:latin typeface="Calibri"/>
-              </a:rPr>
-              <a:t>event occurs</a:t>
-            </a:r>
-            <a:endParaRPr sz="1500" b="0" dirty="0">
-              <a:solidFill>
-                <a:srgbClr val="212121"/>
-              </a:solidFill>
-              <a:latin typeface="Calibri"/>
-            </a:endParaRPr>
-          </a:p>
-          <a:p>
-            <a:pPr>
-              <a:spcAft>
-                <a:spcPts val="1100"/>
-              </a:spcAft>
-            </a:pPr>
-            <a:r>
-              <a:rPr sz="1600" b="0" dirty="0">
-                <a:solidFill>
-                  <a:srgbClr val="1E2761"/>
-                </a:solidFill>
-                <a:latin typeface="Cambria Math"/>
-              </a:rPr>
-              <a:t>P(s | u, </a:t>
-            </a:r>
-            <a:r>
-              <a:rPr sz="1600" b="0" dirty="0" err="1">
-                <a:solidFill>
-                  <a:srgbClr val="1E2761"/>
-                </a:solidFill>
-                <a:latin typeface="Cambria Math"/>
-              </a:rPr>
-              <a:t>τ</a:t>
-            </a:r>
-            <a:r>
-              <a:rPr sz="1600" b="0" dirty="0">
-                <a:solidFill>
-                  <a:srgbClr val="1E2761"/>
-                </a:solidFill>
-                <a:latin typeface="Cambria Math"/>
-              </a:rPr>
-              <a:t>) </a:t>
-            </a:r>
-            <a:r>
-              <a:rPr sz="1500" b="1" dirty="0">
-                <a:solidFill>
-                  <a:srgbClr val="212121"/>
-                </a:solidFill>
-                <a:latin typeface="Calibri"/>
-              </a:rPr>
-              <a:t>size distribution of events </a:t>
-            </a:r>
-            <a:r>
-              <a:rPr sz="1500" b="0" dirty="0">
-                <a:solidFill>
-                  <a:srgbClr val="212121"/>
-                </a:solidFill>
-                <a:latin typeface="Calibri"/>
-              </a:rPr>
-              <a:t>at a given state</a:t>
-            </a:r>
-          </a:p>
-          <a:p>
-            <a:pPr>
-              <a:spcAft>
-                <a:spcPts val="1100"/>
-              </a:spcAft>
-            </a:pPr>
-            <a:r>
-              <a:rPr sz="1600" b="0" dirty="0" err="1">
-                <a:solidFill>
-                  <a:srgbClr val="1E2761"/>
-                </a:solidFill>
-                <a:latin typeface="Cambria Math"/>
-              </a:rPr>
-              <a:t>s_c</a:t>
-            </a:r>
-            <a:r>
-              <a:rPr sz="1600" b="0" dirty="0">
-                <a:solidFill>
-                  <a:srgbClr val="1E2761"/>
-                </a:solidFill>
-                <a:latin typeface="Cambria Math"/>
-              </a:rPr>
-              <a:t>(u, </a:t>
-            </a:r>
-            <a:r>
-              <a:rPr sz="1600" b="0" dirty="0" err="1">
-                <a:solidFill>
-                  <a:srgbClr val="1E2761"/>
-                </a:solidFill>
-                <a:latin typeface="Cambria Math"/>
-              </a:rPr>
-              <a:t>τ</a:t>
-            </a:r>
-            <a:r>
-              <a:rPr sz="1600" b="0" dirty="0">
-                <a:solidFill>
-                  <a:srgbClr val="1E2761"/>
-                </a:solidFill>
-                <a:latin typeface="Cambria Math"/>
-              </a:rPr>
-              <a:t>) </a:t>
-            </a:r>
-            <a:r>
-              <a:rPr sz="1500" b="1" dirty="0">
-                <a:solidFill>
-                  <a:srgbClr val="212121"/>
-                </a:solidFill>
-                <a:latin typeface="Calibri"/>
-              </a:rPr>
-              <a:t>the largest event </a:t>
-            </a:r>
-            <a:r>
-              <a:rPr sz="1500" b="0" dirty="0">
-                <a:solidFill>
-                  <a:srgbClr val="212121"/>
-                </a:solidFill>
-                <a:latin typeface="Calibri"/>
-              </a:rPr>
-              <a:t>a state can produce</a:t>
-            </a:r>
-          </a:p>
-          <a:p>
-            <a:pPr>
-              <a:spcAft>
-                <a:spcPts val="1100"/>
-              </a:spcAft>
-            </a:pPr>
-            <a:r>
-              <a:rPr sz="1600" b="0" dirty="0">
-                <a:solidFill>
-                  <a:srgbClr val="1E2761"/>
-                </a:solidFill>
-                <a:latin typeface="Cambria Math"/>
-              </a:rPr>
-              <a:t>k, m, </a:t>
-            </a:r>
-            <a:r>
-              <a:rPr sz="1600" b="0" dirty="0" err="1">
-                <a:solidFill>
-                  <a:srgbClr val="1E2761"/>
-                </a:solidFill>
-                <a:latin typeface="Cambria Math"/>
-              </a:rPr>
-              <a:t>ε</a:t>
-            </a:r>
-            <a:r>
-              <a:rPr sz="1600" b="0" dirty="0">
-                <a:solidFill>
-                  <a:srgbClr val="1E2761"/>
-                </a:solidFill>
-                <a:latin typeface="Cambria Math"/>
-              </a:rPr>
-              <a:t>   </a:t>
-            </a:r>
-            <a:r>
-              <a:rPr sz="1500" b="1" dirty="0">
-                <a:solidFill>
-                  <a:srgbClr val="212121"/>
-                </a:solidFill>
-                <a:latin typeface="Calibri"/>
-              </a:rPr>
-              <a:t>constants </a:t>
-            </a:r>
-            <a:endParaRPr lang="en-US" sz="1500" b="1" dirty="0">
-              <a:solidFill>
-                <a:srgbClr val="212121"/>
-              </a:solidFill>
-              <a:latin typeface="Calibri"/>
-            </a:endParaRPr>
-          </a:p>
-          <a:p>
-            <a:pPr>
-              <a:spcAft>
-                <a:spcPts val="1100"/>
-              </a:spcAft>
-            </a:pPr>
-            <a:r>
-              <a:rPr sz="1600" b="0" dirty="0">
-                <a:solidFill>
-                  <a:srgbClr val="1E2761"/>
-                </a:solidFill>
-                <a:latin typeface="Cambria Math"/>
-              </a:rPr>
-              <a:t>q(u, </a:t>
-            </a:r>
-            <a:r>
-              <a:rPr sz="1600" b="0" dirty="0" err="1">
-                <a:solidFill>
-                  <a:srgbClr val="1E2761"/>
-                </a:solidFill>
-                <a:latin typeface="Cambria Math"/>
-              </a:rPr>
-              <a:t>τ</a:t>
-            </a:r>
-            <a:r>
-              <a:rPr sz="1600" b="0" dirty="0">
-                <a:solidFill>
-                  <a:srgbClr val="1E2761"/>
-                </a:solidFill>
-                <a:latin typeface="Cambria Math"/>
-              </a:rPr>
-              <a:t>)   </a:t>
-            </a:r>
-            <a:r>
-              <a:rPr sz="1500" b="0" dirty="0">
-                <a:solidFill>
-                  <a:srgbClr val="212121"/>
-                </a:solidFill>
-                <a:latin typeface="Calibri"/>
-              </a:rPr>
-              <a:t>plastic fraction of the strain rate</a:t>
-            </a:r>
-            <a:r>
-              <a:rPr lang="en-US" sz="1500" dirty="0">
-                <a:solidFill>
-                  <a:srgbClr val="212121"/>
-                </a:solidFill>
-                <a:latin typeface="Calibri"/>
-              </a:rPr>
-              <a:t>:</a:t>
-            </a:r>
-            <a:r>
-              <a:rPr sz="1500" b="0" dirty="0">
-                <a:solidFill>
-                  <a:srgbClr val="212121"/>
-                </a:solidFill>
-                <a:latin typeface="Calibri"/>
-              </a:rPr>
-              <a:t> 0</a:t>
-            </a:r>
-            <a:r>
-              <a:rPr lang="en-US" sz="1500" b="0" dirty="0">
-                <a:solidFill>
-                  <a:srgbClr val="212121"/>
-                </a:solidFill>
-                <a:latin typeface="Calibri"/>
-              </a:rPr>
-              <a:t>-&gt;</a:t>
-            </a:r>
-            <a:r>
-              <a:rPr sz="1500" b="0" dirty="0">
-                <a:solidFill>
-                  <a:srgbClr val="212121"/>
-                </a:solidFill>
-                <a:latin typeface="Calibri"/>
-              </a:rPr>
-              <a:t>elastic, 1</a:t>
-            </a:r>
-            <a:r>
-              <a:rPr lang="en-US" sz="1500" b="0" dirty="0">
-                <a:solidFill>
-                  <a:srgbClr val="212121"/>
-                </a:solidFill>
-                <a:latin typeface="Calibri"/>
-              </a:rPr>
-              <a:t>-&gt;</a:t>
-            </a:r>
-            <a:r>
-              <a:rPr sz="1500" b="0" dirty="0">
-                <a:solidFill>
-                  <a:srgbClr val="212121"/>
-                </a:solidFill>
-                <a:latin typeface="Calibri"/>
-              </a:rPr>
-              <a:t>steady </a:t>
-            </a:r>
-            <a:r>
-              <a:rPr lang="en-US" sz="1500" b="0" dirty="0">
-                <a:solidFill>
-                  <a:srgbClr val="212121"/>
-                </a:solidFill>
-                <a:latin typeface="Calibri"/>
-              </a:rPr>
-              <a:t>state</a:t>
-            </a:r>
-          </a:p>
-          <a:p>
-            <a:pPr>
-              <a:spcAft>
-                <a:spcPts val="1100"/>
-              </a:spcAft>
-            </a:pPr>
-            <a:r>
-              <a:rPr lang="en-US" sz="1500" dirty="0">
-                <a:solidFill>
-                  <a:srgbClr val="212121"/>
-                </a:solidFill>
-                <a:latin typeface="Calibri"/>
-              </a:rPr>
-              <a:t>	eq.-&gt; </a:t>
-            </a:r>
-            <a:r>
-              <a:rPr lang="en-US" sz="1500" dirty="0">
-                <a:solidFill>
-                  <a:srgbClr val="212121"/>
-                </a:solidFill>
-              </a:rPr>
-              <a:t>q = 1 − (d</a:t>
-            </a:r>
-            <a:r>
-              <a:rPr lang="el-GR" sz="1500" dirty="0">
-                <a:solidFill>
-                  <a:srgbClr val="212121"/>
-                </a:solidFill>
-              </a:rPr>
-              <a:t>τ/</a:t>
-            </a:r>
-            <a:r>
-              <a:rPr lang="en-US" sz="1500" dirty="0">
-                <a:solidFill>
-                  <a:srgbClr val="212121"/>
-                </a:solidFill>
-              </a:rPr>
-              <a:t>d</a:t>
-            </a:r>
-            <a:r>
-              <a:rPr lang="el-GR" sz="1500" dirty="0">
-                <a:solidFill>
-                  <a:srgbClr val="212121"/>
-                </a:solidFill>
-              </a:rPr>
-              <a:t>γ)/2μ</a:t>
-            </a:r>
-            <a:endParaRPr sz="1500" b="0" dirty="0">
-              <a:solidFill>
-                <a:srgbClr val="212121"/>
-              </a:solidFill>
-              <a:latin typeface="Calibri"/>
-            </a:endParaRPr>
-          </a:p>
-          <a:p>
-            <a:pPr>
-              <a:spcAft>
-                <a:spcPts val="1100"/>
-              </a:spcAft>
-            </a:pPr>
-            <a:r>
-              <a:rPr sz="1600" b="0" dirty="0">
-                <a:solidFill>
-                  <a:srgbClr val="1E2761"/>
-                </a:solidFill>
-                <a:latin typeface="Cambria Math"/>
-              </a:rPr>
-              <a:t>aging event   </a:t>
-            </a:r>
-            <a:r>
-              <a:rPr sz="1500" b="0" dirty="0">
-                <a:solidFill>
-                  <a:srgbClr val="212121"/>
-                </a:solidFill>
-                <a:latin typeface="Calibri"/>
-              </a:rPr>
-              <a:t>a step where u drops but </a:t>
-            </a:r>
-            <a:r>
-              <a:rPr sz="1500" b="0" dirty="0" err="1">
-                <a:solidFill>
-                  <a:srgbClr val="212121"/>
-                </a:solidFill>
-                <a:latin typeface="Calibri"/>
-              </a:rPr>
-              <a:t>τ</a:t>
-            </a:r>
-            <a:r>
-              <a:rPr sz="1500" b="0" dirty="0">
-                <a:solidFill>
-                  <a:srgbClr val="212121"/>
-                </a:solidFill>
-                <a:latin typeface="Calibri"/>
-              </a:rPr>
-              <a:t> does not (105,188); it relaxes energy without releasing stress</a:t>
-            </a:r>
-          </a:p>
-        </p:txBody>
-      </p:sp>
+      </p:pic>
     </p:spTree>
+    <p:extLst>
+      <p:ext uri="{BB962C8B-B14F-4D97-AF65-F5344CB8AC3E}">
+        <p14:creationId xmlns:p14="http://schemas.microsoft.com/office/powerpoint/2010/main" val="1062623640"/>
+      </p:ext>
+    </p:extLst>
   </p:cSld>
   <p:clrMapOvr>
     <a:masterClrMapping/>
@@ -4039,6 +3712,1282 @@
           <a:chExt cx="0" cy="0"/>
         </a:xfrm>
       </p:grpSpPr>
+      <p:pic>
+        <p:nvPicPr>
+          <p:cNvPr id="3" name="Picture 2">
+            <a:extLst>
+              <a:ext uri="{FF2B5EF4-FFF2-40B4-BE49-F238E27FC236}">
+                <a16:creationId xmlns:a16="http://schemas.microsoft.com/office/drawing/2014/main" id="{618DF928-620E-5150-16B6-DAF177D1222C}"/>
+              </a:ext>
+            </a:extLst>
+          </p:cNvPr>
+          <p:cNvPicPr>
+            <a:picLocks noChangeAspect="1"/>
+          </p:cNvPicPr>
+          <p:nvPr/>
+        </p:nvPicPr>
+        <p:blipFill>
+          <a:blip r:embed="rId2"/>
+          <a:stretch>
+            <a:fillRect/>
+          </a:stretch>
+        </p:blipFill>
+        <p:spPr>
+          <a:xfrm>
+            <a:off x="748921" y="603885"/>
+            <a:ext cx="10694158" cy="5650230"/>
+          </a:xfrm>
+          <a:prstGeom prst="rect">
+            <a:avLst/>
+          </a:prstGeom>
+        </p:spPr>
+      </p:pic>
+    </p:spTree>
+    <p:extLst>
+      <p:ext uri="{BB962C8B-B14F-4D97-AF65-F5344CB8AC3E}">
+        <p14:creationId xmlns:p14="http://schemas.microsoft.com/office/powerpoint/2010/main" val="2722914318"/>
+      </p:ext>
+    </p:extLst>
+  </p:cSld>
+  <p:clrMapOvr>
+    <a:masterClrMapping/>
+  </p:clrMapOvr>
+</p:sld>
+</file>
+
+<file path=ppt/slides/slide4.xml><?xml version="1.0" encoding="utf-8"?>
+<p:sld xmlns:a="http://schemas.openxmlformats.org/drawingml/2006/main" xmlns:r="http://schemas.openxmlformats.org/officeDocument/2006/relationships" xmlns:p="http://schemas.openxmlformats.org/presentationml/2006/main">
+  <p:cSld>
+    <p:spTree>
+      <p:nvGrpSpPr>
+        <p:cNvPr id="1" name=""/>
+        <p:cNvGrpSpPr/>
+        <p:nvPr/>
+      </p:nvGrpSpPr>
+      <p:grpSpPr>
+        <a:xfrm>
+          <a:off x="0" y="0"/>
+          <a:ext cx="0" cy="0"/>
+          <a:chOff x="0" y="0"/>
+          <a:chExt cx="0" cy="0"/>
+        </a:xfrm>
+      </p:grpSpPr>
+      <p:grpSp>
+        <p:nvGrpSpPr>
+          <p:cNvPr id="5" name="Group 4">
+            <a:extLst>
+              <a:ext uri="{FF2B5EF4-FFF2-40B4-BE49-F238E27FC236}">
+                <a16:creationId xmlns:a16="http://schemas.microsoft.com/office/drawing/2014/main" id="{71ED3E02-89F8-CBE8-0616-E295031E4CB3}"/>
+              </a:ext>
+            </a:extLst>
+          </p:cNvPr>
+          <p:cNvGrpSpPr/>
+          <p:nvPr/>
+        </p:nvGrpSpPr>
+        <p:grpSpPr>
+          <a:xfrm>
+            <a:off x="0" y="0"/>
+            <a:ext cx="6785610" cy="914624"/>
+            <a:chOff x="2091690" y="2312670"/>
+            <a:chExt cx="6785610" cy="914624"/>
+          </a:xfrm>
+        </p:grpSpPr>
+        <p:pic>
+          <p:nvPicPr>
+            <p:cNvPr id="2" name="Picture 1">
+              <a:extLst>
+                <a:ext uri="{FF2B5EF4-FFF2-40B4-BE49-F238E27FC236}">
+                  <a16:creationId xmlns:a16="http://schemas.microsoft.com/office/drawing/2014/main" id="{2B4D5B55-F1EF-1E32-59E7-8879AB6FB744}"/>
+                </a:ext>
+              </a:extLst>
+            </p:cNvPr>
+            <p:cNvPicPr>
+              <a:picLocks noChangeAspect="1"/>
+            </p:cNvPicPr>
+            <p:nvPr/>
+          </p:nvPicPr>
+          <p:blipFill>
+            <a:blip r:embed="rId2"/>
+            <a:srcRect t="-1" b="8369"/>
+            <a:stretch>
+              <a:fillRect/>
+            </a:stretch>
+          </p:blipFill>
+          <p:spPr>
+            <a:xfrm>
+              <a:off x="2628900" y="2715260"/>
+              <a:ext cx="6248400" cy="512034"/>
+            </a:xfrm>
+            <a:prstGeom prst="rect">
+              <a:avLst/>
+            </a:prstGeom>
+          </p:spPr>
+        </p:pic>
+        <p:pic>
+          <p:nvPicPr>
+            <p:cNvPr id="4" name="Picture 3">
+              <a:extLst>
+                <a:ext uri="{FF2B5EF4-FFF2-40B4-BE49-F238E27FC236}">
+                  <a16:creationId xmlns:a16="http://schemas.microsoft.com/office/drawing/2014/main" id="{DB278F5B-D3BF-CD2A-4AB6-6A4CB9505D97}"/>
+                </a:ext>
+              </a:extLst>
+            </p:cNvPr>
+            <p:cNvPicPr>
+              <a:picLocks noChangeAspect="1"/>
+            </p:cNvPicPr>
+            <p:nvPr/>
+          </p:nvPicPr>
+          <p:blipFill>
+            <a:blip r:embed="rId3"/>
+            <a:stretch>
+              <a:fillRect/>
+            </a:stretch>
+          </p:blipFill>
+          <p:spPr>
+            <a:xfrm>
+              <a:off x="2091690" y="2312670"/>
+              <a:ext cx="3048000" cy="647700"/>
+            </a:xfrm>
+            <a:prstGeom prst="rect">
+              <a:avLst/>
+            </a:prstGeom>
+          </p:spPr>
+        </p:pic>
+      </p:grpSp>
+      <p:sp>
+        <p:nvSpPr>
+          <p:cNvPr id="6" name="TextBox 5">
+            <a:extLst>
+              <a:ext uri="{FF2B5EF4-FFF2-40B4-BE49-F238E27FC236}">
+                <a16:creationId xmlns:a16="http://schemas.microsoft.com/office/drawing/2014/main" id="{C7C8B0C8-CB97-3B61-B118-AAFB741DAEB0}"/>
+              </a:ext>
+            </a:extLst>
+          </p:cNvPr>
+          <p:cNvSpPr txBox="1"/>
+          <p:nvPr/>
+        </p:nvSpPr>
+        <p:spPr>
+          <a:xfrm>
+            <a:off x="5503209" y="1132548"/>
+            <a:ext cx="2196692" cy="369332"/>
+          </a:xfrm>
+          <a:prstGeom prst="rect">
+            <a:avLst/>
+          </a:prstGeom>
+          <a:noFill/>
+        </p:spPr>
+        <p:txBody>
+          <a:bodyPr wrap="none" rtlCol="0">
+            <a:spAutoFit/>
+          </a:bodyPr>
+          <a:lstStyle/>
+          <a:p>
+            <a:r>
+              <a:rPr lang="en-US" b="1" dirty="0"/>
+              <a:t>Truncated power law</a:t>
+            </a:r>
+          </a:p>
+        </p:txBody>
+      </p:sp>
+      <p:cxnSp>
+        <p:nvCxnSpPr>
+          <p:cNvPr id="8" name="Straight Arrow Connector 7">
+            <a:extLst>
+              <a:ext uri="{FF2B5EF4-FFF2-40B4-BE49-F238E27FC236}">
+                <a16:creationId xmlns:a16="http://schemas.microsoft.com/office/drawing/2014/main" id="{B1661309-06C9-CDCD-7642-2067366BA790}"/>
+              </a:ext>
+            </a:extLst>
+          </p:cNvPr>
+          <p:cNvCxnSpPr/>
+          <p:nvPr/>
+        </p:nvCxnSpPr>
+        <p:spPr>
+          <a:xfrm flipH="1" flipV="1">
+            <a:off x="4931709" y="1023586"/>
+            <a:ext cx="571500" cy="217924"/>
+          </a:xfrm>
+          <a:prstGeom prst="straightConnector1">
+            <a:avLst/>
+          </a:prstGeom>
+          <a:ln>
+            <a:tailEnd type="triangle"/>
+          </a:ln>
+        </p:spPr>
+        <p:style>
+          <a:lnRef idx="2">
+            <a:schemeClr val="accent1"/>
+          </a:lnRef>
+          <a:fillRef idx="0">
+            <a:schemeClr val="accent1"/>
+          </a:fillRef>
+          <a:effectRef idx="1">
+            <a:schemeClr val="accent1"/>
+          </a:effectRef>
+          <a:fontRef idx="minor">
+            <a:schemeClr val="tx1"/>
+          </a:fontRef>
+        </p:style>
+      </p:cxnSp>
+      <p:cxnSp>
+        <p:nvCxnSpPr>
+          <p:cNvPr id="10" name="Straight Connector 9">
+            <a:extLst>
+              <a:ext uri="{FF2B5EF4-FFF2-40B4-BE49-F238E27FC236}">
+                <a16:creationId xmlns:a16="http://schemas.microsoft.com/office/drawing/2014/main" id="{8E661651-B1C7-34B4-2245-7E76A8DED53C}"/>
+              </a:ext>
+            </a:extLst>
+          </p:cNvPr>
+          <p:cNvCxnSpPr/>
+          <p:nvPr/>
+        </p:nvCxnSpPr>
+        <p:spPr>
+          <a:xfrm>
+            <a:off x="3491529" y="951012"/>
+            <a:ext cx="2274570" cy="0"/>
+          </a:xfrm>
+          <a:prstGeom prst="line">
+            <a:avLst/>
+          </a:prstGeom>
+        </p:spPr>
+        <p:style>
+          <a:lnRef idx="2">
+            <a:schemeClr val="accent1"/>
+          </a:lnRef>
+          <a:fillRef idx="0">
+            <a:schemeClr val="accent1"/>
+          </a:fillRef>
+          <a:effectRef idx="1">
+            <a:schemeClr val="accent1"/>
+          </a:effectRef>
+          <a:fontRef idx="minor">
+            <a:schemeClr val="tx1"/>
+          </a:fontRef>
+        </p:style>
+      </p:cxnSp>
+      <p:sp>
+        <p:nvSpPr>
+          <p:cNvPr id="14" name="TextBox 13">
+            <a:extLst>
+              <a:ext uri="{FF2B5EF4-FFF2-40B4-BE49-F238E27FC236}">
+                <a16:creationId xmlns:a16="http://schemas.microsoft.com/office/drawing/2014/main" id="{A58133CD-C581-EAAD-2C79-B487D2B9B9D9}"/>
+              </a:ext>
+            </a:extLst>
+          </p:cNvPr>
+          <p:cNvSpPr txBox="1"/>
+          <p:nvPr/>
+        </p:nvSpPr>
+        <p:spPr>
+          <a:xfrm>
+            <a:off x="3736658" y="1575479"/>
+            <a:ext cx="6097904" cy="369332"/>
+          </a:xfrm>
+          <a:prstGeom prst="rect">
+            <a:avLst/>
+          </a:prstGeom>
+          <a:noFill/>
+        </p:spPr>
+        <p:txBody>
+          <a:bodyPr wrap="square">
+            <a:spAutoFit/>
+          </a:bodyPr>
+          <a:lstStyle/>
+          <a:p>
+            <a:r>
+              <a:rPr lang="en-US" b="1" dirty="0"/>
+              <a:t>“we find that a simple exponential tail does not fit our data.”</a:t>
+            </a:r>
+          </a:p>
+        </p:txBody>
+      </p:sp>
+      <p:grpSp>
+        <p:nvGrpSpPr>
+          <p:cNvPr id="17" name="Group 16">
+            <a:extLst>
+              <a:ext uri="{FF2B5EF4-FFF2-40B4-BE49-F238E27FC236}">
+                <a16:creationId xmlns:a16="http://schemas.microsoft.com/office/drawing/2014/main" id="{F1F8297E-6DE9-015C-5677-EEFEACE21229}"/>
+              </a:ext>
+            </a:extLst>
+          </p:cNvPr>
+          <p:cNvGrpSpPr/>
+          <p:nvPr/>
+        </p:nvGrpSpPr>
+        <p:grpSpPr>
+          <a:xfrm>
+            <a:off x="3491529" y="2018410"/>
+            <a:ext cx="5975032" cy="4840168"/>
+            <a:chOff x="3736658" y="2006151"/>
+            <a:chExt cx="5975032" cy="4840168"/>
+          </a:xfrm>
+        </p:grpSpPr>
+        <p:pic>
+          <p:nvPicPr>
+            <p:cNvPr id="12" name="Picture 11">
+              <a:extLst>
+                <a:ext uri="{FF2B5EF4-FFF2-40B4-BE49-F238E27FC236}">
+                  <a16:creationId xmlns:a16="http://schemas.microsoft.com/office/drawing/2014/main" id="{268981AE-42DC-5848-D612-D1B4CCEF9DD8}"/>
+                </a:ext>
+              </a:extLst>
+            </p:cNvPr>
+            <p:cNvPicPr>
+              <a:picLocks noChangeAspect="1"/>
+            </p:cNvPicPr>
+            <p:nvPr/>
+          </p:nvPicPr>
+          <p:blipFill>
+            <a:blip r:embed="rId4"/>
+            <a:srcRect t="1069" b="1"/>
+            <a:stretch>
+              <a:fillRect/>
+            </a:stretch>
+          </p:blipFill>
+          <p:spPr>
+            <a:xfrm>
+              <a:off x="3859530" y="2327632"/>
+              <a:ext cx="5852160" cy="4518687"/>
+            </a:xfrm>
+            <a:prstGeom prst="rect">
+              <a:avLst/>
+            </a:prstGeom>
+          </p:spPr>
+        </p:pic>
+        <p:pic>
+          <p:nvPicPr>
+            <p:cNvPr id="16" name="Picture 15">
+              <a:extLst>
+                <a:ext uri="{FF2B5EF4-FFF2-40B4-BE49-F238E27FC236}">
+                  <a16:creationId xmlns:a16="http://schemas.microsoft.com/office/drawing/2014/main" id="{CF2C66DA-6313-68C6-8DCC-986ABD024676}"/>
+                </a:ext>
+              </a:extLst>
+            </p:cNvPr>
+            <p:cNvPicPr>
+              <a:picLocks noChangeAspect="1"/>
+            </p:cNvPicPr>
+            <p:nvPr/>
+          </p:nvPicPr>
+          <p:blipFill>
+            <a:blip r:embed="rId5"/>
+            <a:stretch>
+              <a:fillRect/>
+            </a:stretch>
+          </p:blipFill>
+          <p:spPr>
+            <a:xfrm>
+              <a:off x="3736658" y="2006151"/>
+              <a:ext cx="647700" cy="520700"/>
+            </a:xfrm>
+            <a:prstGeom prst="rect">
+              <a:avLst/>
+            </a:prstGeom>
+          </p:spPr>
+        </p:pic>
+      </p:grpSp>
+      <p:cxnSp>
+        <p:nvCxnSpPr>
+          <p:cNvPr id="19" name="Straight Connector 18">
+            <a:extLst>
+              <a:ext uri="{FF2B5EF4-FFF2-40B4-BE49-F238E27FC236}">
+                <a16:creationId xmlns:a16="http://schemas.microsoft.com/office/drawing/2014/main" id="{1D21D286-4AB7-B23B-A0B1-405099AE2D74}"/>
+              </a:ext>
+            </a:extLst>
+          </p:cNvPr>
+          <p:cNvCxnSpPr>
+            <a:cxnSpLocks/>
+          </p:cNvCxnSpPr>
+          <p:nvPr/>
+        </p:nvCxnSpPr>
+        <p:spPr>
+          <a:xfrm>
+            <a:off x="8381999" y="2539110"/>
+            <a:ext cx="1042997" cy="0"/>
+          </a:xfrm>
+          <a:prstGeom prst="line">
+            <a:avLst/>
+          </a:prstGeom>
+        </p:spPr>
+        <p:style>
+          <a:lnRef idx="2">
+            <a:schemeClr val="accent1"/>
+          </a:lnRef>
+          <a:fillRef idx="0">
+            <a:schemeClr val="accent1"/>
+          </a:fillRef>
+          <a:effectRef idx="1">
+            <a:schemeClr val="accent1"/>
+          </a:effectRef>
+          <a:fontRef idx="minor">
+            <a:schemeClr val="tx1"/>
+          </a:fontRef>
+        </p:style>
+      </p:cxnSp>
+    </p:spTree>
+    <p:extLst>
+      <p:ext uri="{BB962C8B-B14F-4D97-AF65-F5344CB8AC3E}">
+        <p14:creationId xmlns:p14="http://schemas.microsoft.com/office/powerpoint/2010/main" val="1975909919"/>
+      </p:ext>
+    </p:extLst>
+  </p:cSld>
+  <p:clrMapOvr>
+    <a:masterClrMapping/>
+  </p:clrMapOvr>
+</p:sld>
+</file>
+
+<file path=ppt/slides/slide5.xml><?xml version="1.0" encoding="utf-8"?>
+<p:sld xmlns:a="http://schemas.openxmlformats.org/drawingml/2006/main" xmlns:r="http://schemas.openxmlformats.org/officeDocument/2006/relationships" xmlns:p="http://schemas.openxmlformats.org/presentationml/2006/main">
+  <p:cSld>
+    <p:spTree>
+      <p:nvGrpSpPr>
+        <p:cNvPr id="1" name=""/>
+        <p:cNvGrpSpPr/>
+        <p:nvPr/>
+      </p:nvGrpSpPr>
+      <p:grpSpPr>
+        <a:xfrm>
+          <a:off x="0" y="0"/>
+          <a:ext cx="0" cy="0"/>
+          <a:chOff x="0" y="0"/>
+          <a:chExt cx="0" cy="0"/>
+        </a:xfrm>
+      </p:grpSpPr>
+      <p:sp>
+        <p:nvSpPr>
+          <p:cNvPr id="2" name="TextBox 1"/>
+          <p:cNvSpPr txBox="1"/>
+          <p:nvPr/>
+        </p:nvSpPr>
+        <p:spPr>
+          <a:xfrm>
+            <a:off x="548640" y="292608"/>
+            <a:ext cx="11091672" cy="461665"/>
+          </a:xfrm>
+          <a:prstGeom prst="rect">
+            <a:avLst/>
+          </a:prstGeom>
+          <a:noFill/>
+        </p:spPr>
+        <p:txBody>
+          <a:bodyPr wrap="square" lIns="0" tIns="0" rIns="0" bIns="0">
+            <a:spAutoFit/>
+          </a:bodyPr>
+          <a:lstStyle/>
+          <a:p>
+            <a:r>
+              <a:rPr lang="en-US" sz="3000" b="1" dirty="0">
+                <a:solidFill>
+                  <a:srgbClr val="1E2761"/>
+                </a:solidFill>
+                <a:latin typeface="Calibri"/>
+              </a:rPr>
+              <a:t>Variables</a:t>
+            </a:r>
+            <a:endParaRPr sz="3000" b="1" dirty="0">
+              <a:solidFill>
+                <a:srgbClr val="1E2761"/>
+              </a:solidFill>
+              <a:latin typeface="Calibri"/>
+            </a:endParaRPr>
+          </a:p>
+        </p:txBody>
+      </p:sp>
+      <p:sp>
+        <p:nvSpPr>
+          <p:cNvPr id="3" name="TextBox 2"/>
+          <p:cNvSpPr txBox="1"/>
+          <p:nvPr/>
+        </p:nvSpPr>
+        <p:spPr>
+          <a:xfrm>
+            <a:off x="640080" y="1234440"/>
+            <a:ext cx="5394960" cy="2182649"/>
+          </a:xfrm>
+          <a:prstGeom prst="rect">
+            <a:avLst/>
+          </a:prstGeom>
+          <a:noFill/>
+        </p:spPr>
+        <p:txBody>
+          <a:bodyPr wrap="square" lIns="0" tIns="0" rIns="0" bIns="0">
+            <a:spAutoFit/>
+          </a:bodyPr>
+          <a:lstStyle/>
+          <a:p>
+            <a:pPr>
+              <a:spcAft>
+                <a:spcPts val="1100"/>
+              </a:spcAft>
+            </a:pPr>
+            <a:r>
+              <a:rPr sz="1600" b="0" dirty="0" err="1">
+                <a:solidFill>
+                  <a:srgbClr val="1E2761"/>
+                </a:solidFill>
+                <a:latin typeface="Cambria Math"/>
+              </a:rPr>
+              <a:t>γ</a:t>
+            </a:r>
+            <a:r>
+              <a:rPr sz="1600" b="0" dirty="0">
+                <a:solidFill>
+                  <a:srgbClr val="1E2761"/>
+                </a:solidFill>
+                <a:latin typeface="Cambria Math"/>
+              </a:rPr>
+              <a:t>   </a:t>
+            </a:r>
+            <a:r>
+              <a:rPr sz="1500" b="0" dirty="0">
+                <a:solidFill>
+                  <a:srgbClr val="212121"/>
+                </a:solidFill>
+                <a:latin typeface="Calibri"/>
+              </a:rPr>
+              <a:t>applied shear strain; one step is 10⁻⁵, runs go to 0.5</a:t>
+            </a:r>
+          </a:p>
+          <a:p>
+            <a:pPr>
+              <a:spcAft>
+                <a:spcPts val="1100"/>
+              </a:spcAft>
+            </a:pPr>
+            <a:r>
+              <a:rPr sz="1600" b="0" dirty="0" err="1">
+                <a:solidFill>
+                  <a:srgbClr val="1E2761"/>
+                </a:solidFill>
+                <a:latin typeface="Cambria Math"/>
+              </a:rPr>
+              <a:t>τ</a:t>
+            </a:r>
+            <a:r>
+              <a:rPr sz="1600" b="0" dirty="0">
+                <a:solidFill>
+                  <a:srgbClr val="1E2761"/>
+                </a:solidFill>
+                <a:latin typeface="Cambria Math"/>
+              </a:rPr>
+              <a:t>   </a:t>
+            </a:r>
+            <a:r>
+              <a:rPr sz="1500" b="0" dirty="0">
+                <a:solidFill>
+                  <a:srgbClr val="212121"/>
+                </a:solidFill>
+                <a:latin typeface="Calibri"/>
+              </a:rPr>
+              <a:t>shear stress (raw stress ÷ 10⁴)</a:t>
+            </a:r>
+          </a:p>
+          <a:p>
+            <a:pPr>
+              <a:spcAft>
+                <a:spcPts val="1100"/>
+              </a:spcAft>
+            </a:pPr>
+            <a:r>
+              <a:rPr sz="1600" b="0" dirty="0">
+                <a:solidFill>
+                  <a:srgbClr val="1E2761"/>
+                </a:solidFill>
+                <a:latin typeface="Cambria Math"/>
+              </a:rPr>
+              <a:t>u = pe − u₀   </a:t>
+            </a:r>
+            <a:r>
+              <a:rPr lang="en-US" sz="1500" b="0" dirty="0">
+                <a:solidFill>
+                  <a:srgbClr val="212121"/>
+                </a:solidFill>
+                <a:latin typeface="Calibri"/>
+              </a:rPr>
+              <a:t>PE/</a:t>
+            </a:r>
+            <a:r>
+              <a:rPr sz="1500" b="0" dirty="0">
+                <a:solidFill>
+                  <a:srgbClr val="212121"/>
+                </a:solidFill>
+                <a:latin typeface="Calibri"/>
+              </a:rPr>
+              <a:t>atom above the reference u₀ = −4.60752</a:t>
+            </a:r>
+          </a:p>
+          <a:p>
+            <a:pPr>
+              <a:spcAft>
+                <a:spcPts val="1100"/>
+              </a:spcAft>
+            </a:pPr>
+            <a:r>
+              <a:rPr sz="1600" b="0" dirty="0">
+                <a:solidFill>
+                  <a:srgbClr val="1E2761"/>
+                </a:solidFill>
+                <a:latin typeface="Cambria Math"/>
+              </a:rPr>
+              <a:t>(u, </a:t>
+            </a:r>
+            <a:r>
+              <a:rPr sz="1600" b="0" dirty="0" err="1">
+                <a:solidFill>
+                  <a:srgbClr val="1E2761"/>
+                </a:solidFill>
+                <a:latin typeface="Cambria Math"/>
+              </a:rPr>
+              <a:t>τ</a:t>
+            </a:r>
+            <a:r>
+              <a:rPr sz="1600" b="0" dirty="0">
+                <a:solidFill>
+                  <a:srgbClr val="1E2761"/>
+                </a:solidFill>
+                <a:latin typeface="Cambria Math"/>
+              </a:rPr>
+              <a:t>) </a:t>
+            </a:r>
+            <a:r>
+              <a:rPr sz="1500" b="0" dirty="0">
+                <a:solidFill>
+                  <a:srgbClr val="212121"/>
+                </a:solidFill>
+                <a:latin typeface="Calibri"/>
+              </a:rPr>
+              <a:t>two-coordinate state of a run; 20 × 20 grid</a:t>
+            </a:r>
+          </a:p>
+          <a:p>
+            <a:pPr>
+              <a:spcAft>
+                <a:spcPts val="1100"/>
+              </a:spcAft>
+            </a:pPr>
+            <a:r>
+              <a:rPr sz="1600" b="0" dirty="0">
+                <a:solidFill>
+                  <a:srgbClr val="1E2761"/>
+                </a:solidFill>
+                <a:latin typeface="Cambria Math"/>
+              </a:rPr>
+              <a:t>2μ(u, </a:t>
+            </a:r>
+            <a:r>
+              <a:rPr sz="1600" b="0" dirty="0" err="1">
+                <a:solidFill>
+                  <a:srgbClr val="1E2761"/>
+                </a:solidFill>
+                <a:latin typeface="Cambria Math"/>
+              </a:rPr>
+              <a:t>τ</a:t>
+            </a:r>
+            <a:r>
+              <a:rPr sz="1600" b="0" dirty="0">
+                <a:solidFill>
+                  <a:srgbClr val="1E2761"/>
+                </a:solidFill>
+                <a:latin typeface="Cambria Math"/>
+              </a:rPr>
+              <a:t>)   </a:t>
+            </a:r>
+            <a:r>
+              <a:rPr sz="1500" b="0" dirty="0">
+                <a:solidFill>
+                  <a:srgbClr val="212121"/>
+                </a:solidFill>
+                <a:latin typeface="Calibri"/>
+              </a:rPr>
+              <a:t>elastic modulus</a:t>
+            </a:r>
+          </a:p>
+          <a:p>
+            <a:pPr>
+              <a:spcAft>
+                <a:spcPts val="1100"/>
+              </a:spcAft>
+            </a:pPr>
+            <a:r>
+              <a:rPr sz="1600" b="0" dirty="0">
+                <a:solidFill>
+                  <a:srgbClr val="1E2761"/>
+                </a:solidFill>
+                <a:latin typeface="Cambria Math"/>
+              </a:rPr>
+              <a:t>s = −</a:t>
+            </a:r>
+            <a:r>
+              <a:rPr sz="1600" b="0" dirty="0" err="1">
+                <a:solidFill>
+                  <a:srgbClr val="1E2761"/>
+                </a:solidFill>
+                <a:latin typeface="Cambria Math"/>
+              </a:rPr>
+              <a:t>Δτ</a:t>
+            </a:r>
+            <a:r>
+              <a:rPr sz="1600" b="0" dirty="0">
+                <a:solidFill>
+                  <a:srgbClr val="1E2761"/>
+                </a:solidFill>
+                <a:latin typeface="Cambria Math"/>
+              </a:rPr>
+              <a:t> </a:t>
+            </a:r>
+            <a:r>
+              <a:rPr lang="en-US" sz="1600" b="0" dirty="0">
+                <a:solidFill>
+                  <a:srgbClr val="1E2761"/>
+                </a:solidFill>
+                <a:latin typeface="Cambria Math"/>
+              </a:rPr>
+              <a:t>  </a:t>
+            </a:r>
+            <a:r>
+              <a:rPr lang="en-US" sz="1500" b="0" dirty="0">
+                <a:solidFill>
+                  <a:srgbClr val="212121"/>
+                </a:solidFill>
+                <a:latin typeface="Calibri"/>
+              </a:rPr>
+              <a:t>an </a:t>
+            </a:r>
+            <a:r>
+              <a:rPr sz="1500" b="0" dirty="0">
+                <a:solidFill>
+                  <a:srgbClr val="212121"/>
+                </a:solidFill>
+                <a:latin typeface="Calibri"/>
+              </a:rPr>
+              <a:t>event: a step where the stress drops, of size s</a:t>
+            </a:r>
+          </a:p>
+        </p:txBody>
+      </p:sp>
+      <p:sp>
+        <p:nvSpPr>
+          <p:cNvPr id="4" name="TextBox 3"/>
+          <p:cNvSpPr txBox="1"/>
+          <p:nvPr/>
+        </p:nvSpPr>
+        <p:spPr>
+          <a:xfrm>
+            <a:off x="6355080" y="1234440"/>
+            <a:ext cx="5303520" cy="3172663"/>
+          </a:xfrm>
+          <a:prstGeom prst="rect">
+            <a:avLst/>
+          </a:prstGeom>
+          <a:noFill/>
+        </p:spPr>
+        <p:txBody>
+          <a:bodyPr wrap="square" lIns="0" tIns="0" rIns="0" bIns="0">
+            <a:spAutoFit/>
+          </a:bodyPr>
+          <a:lstStyle/>
+          <a:p>
+            <a:pPr>
+              <a:spcAft>
+                <a:spcPts val="1100"/>
+              </a:spcAft>
+            </a:pPr>
+            <a:r>
+              <a:rPr lang="el-GR" sz="1600" dirty="0">
+                <a:solidFill>
+                  <a:srgbClr val="1E2761"/>
+                </a:solidFill>
+                <a:latin typeface="Cambria Math"/>
+              </a:rPr>
+              <a:t>ρ(</a:t>
+            </a:r>
+            <a:r>
+              <a:rPr lang="en-US" sz="1600" dirty="0">
+                <a:solidFill>
+                  <a:srgbClr val="1E2761"/>
+                </a:solidFill>
+                <a:latin typeface="Cambria Math"/>
+              </a:rPr>
+              <a:t>s) </a:t>
+            </a:r>
+            <a:r>
+              <a:rPr lang="en-US" sz="1600" b="1" dirty="0">
+                <a:solidFill>
+                  <a:srgbClr val="212121"/>
+                </a:solidFill>
+              </a:rPr>
+              <a:t>density of events </a:t>
+            </a:r>
+            <a:r>
+              <a:rPr lang="en-US" sz="1600" dirty="0">
+                <a:solidFill>
+                  <a:srgbClr val="212121"/>
+                </a:solidFill>
+              </a:rPr>
+              <a:t>of size s</a:t>
+            </a:r>
+            <a:endParaRPr lang="en-US" sz="1600" b="0" dirty="0">
+              <a:solidFill>
+                <a:srgbClr val="1E2761"/>
+              </a:solidFill>
+              <a:latin typeface="Cambria Math"/>
+            </a:endParaRPr>
+          </a:p>
+          <a:p>
+            <a:pPr>
+              <a:spcAft>
+                <a:spcPts val="1100"/>
+              </a:spcAft>
+            </a:pPr>
+            <a:r>
+              <a:rPr sz="1600" b="0" dirty="0">
+                <a:solidFill>
+                  <a:srgbClr val="1E2761"/>
+                </a:solidFill>
+                <a:latin typeface="Cambria Math"/>
+              </a:rPr>
+              <a:t>p(u, </a:t>
+            </a:r>
+            <a:r>
+              <a:rPr sz="1600" b="0" dirty="0" err="1">
+                <a:solidFill>
+                  <a:srgbClr val="1E2761"/>
+                </a:solidFill>
+                <a:latin typeface="Cambria Math"/>
+              </a:rPr>
+              <a:t>τ</a:t>
+            </a:r>
+            <a:r>
+              <a:rPr sz="1600" b="0" dirty="0">
+                <a:solidFill>
+                  <a:srgbClr val="1E2761"/>
+                </a:solidFill>
+                <a:latin typeface="Cambria Math"/>
+              </a:rPr>
+              <a:t>) </a:t>
+            </a:r>
+            <a:r>
+              <a:rPr sz="1500" b="1" dirty="0">
+                <a:solidFill>
+                  <a:srgbClr val="212121"/>
+                </a:solidFill>
+                <a:latin typeface="Calibri"/>
+              </a:rPr>
+              <a:t>probability per step </a:t>
+            </a:r>
+            <a:r>
+              <a:rPr sz="1500" b="0" dirty="0">
+                <a:solidFill>
+                  <a:srgbClr val="212121"/>
+                </a:solidFill>
+                <a:latin typeface="Calibri"/>
+              </a:rPr>
+              <a:t>that an </a:t>
+            </a:r>
+            <a:r>
+              <a:rPr lang="en-US" sz="1500" b="0" dirty="0">
+                <a:solidFill>
+                  <a:srgbClr val="212121"/>
+                </a:solidFill>
+                <a:latin typeface="Calibri"/>
+              </a:rPr>
+              <a:t>event occurs</a:t>
+            </a:r>
+            <a:endParaRPr sz="1500" b="0" dirty="0">
+              <a:solidFill>
+                <a:srgbClr val="212121"/>
+              </a:solidFill>
+              <a:latin typeface="Calibri"/>
+            </a:endParaRPr>
+          </a:p>
+          <a:p>
+            <a:pPr>
+              <a:spcAft>
+                <a:spcPts val="1100"/>
+              </a:spcAft>
+            </a:pPr>
+            <a:r>
+              <a:rPr sz="1600" b="0" dirty="0">
+                <a:solidFill>
+                  <a:srgbClr val="1E2761"/>
+                </a:solidFill>
+                <a:latin typeface="Cambria Math"/>
+              </a:rPr>
+              <a:t>P(s | u, </a:t>
+            </a:r>
+            <a:r>
+              <a:rPr sz="1600" b="0" dirty="0" err="1">
+                <a:solidFill>
+                  <a:srgbClr val="1E2761"/>
+                </a:solidFill>
+                <a:latin typeface="Cambria Math"/>
+              </a:rPr>
+              <a:t>τ</a:t>
+            </a:r>
+            <a:r>
+              <a:rPr sz="1600" b="0" dirty="0">
+                <a:solidFill>
+                  <a:srgbClr val="1E2761"/>
+                </a:solidFill>
+                <a:latin typeface="Cambria Math"/>
+              </a:rPr>
+              <a:t>) </a:t>
+            </a:r>
+            <a:r>
+              <a:rPr sz="1500" b="1" dirty="0">
+                <a:solidFill>
+                  <a:srgbClr val="212121"/>
+                </a:solidFill>
+                <a:latin typeface="Calibri"/>
+              </a:rPr>
+              <a:t>size distribution of events </a:t>
+            </a:r>
+            <a:r>
+              <a:rPr sz="1500" b="0" dirty="0">
+                <a:solidFill>
+                  <a:srgbClr val="212121"/>
+                </a:solidFill>
+                <a:latin typeface="Calibri"/>
+              </a:rPr>
+              <a:t>at a given state</a:t>
+            </a:r>
+          </a:p>
+          <a:p>
+            <a:pPr>
+              <a:spcAft>
+                <a:spcPts val="1100"/>
+              </a:spcAft>
+            </a:pPr>
+            <a:r>
+              <a:rPr sz="1600" b="0" dirty="0" err="1">
+                <a:solidFill>
+                  <a:srgbClr val="1E2761"/>
+                </a:solidFill>
+                <a:latin typeface="Cambria Math"/>
+              </a:rPr>
+              <a:t>s_c</a:t>
+            </a:r>
+            <a:r>
+              <a:rPr sz="1600" b="0" dirty="0">
+                <a:solidFill>
+                  <a:srgbClr val="1E2761"/>
+                </a:solidFill>
+                <a:latin typeface="Cambria Math"/>
+              </a:rPr>
+              <a:t>(u, </a:t>
+            </a:r>
+            <a:r>
+              <a:rPr sz="1600" b="0" dirty="0" err="1">
+                <a:solidFill>
+                  <a:srgbClr val="1E2761"/>
+                </a:solidFill>
+                <a:latin typeface="Cambria Math"/>
+              </a:rPr>
+              <a:t>τ</a:t>
+            </a:r>
+            <a:r>
+              <a:rPr sz="1600" b="0" dirty="0">
+                <a:solidFill>
+                  <a:srgbClr val="1E2761"/>
+                </a:solidFill>
+                <a:latin typeface="Cambria Math"/>
+              </a:rPr>
+              <a:t>) </a:t>
+            </a:r>
+            <a:r>
+              <a:rPr sz="1500" b="1" dirty="0">
+                <a:solidFill>
+                  <a:srgbClr val="212121"/>
+                </a:solidFill>
+                <a:latin typeface="Calibri"/>
+              </a:rPr>
+              <a:t>the largest event </a:t>
+            </a:r>
+            <a:r>
+              <a:rPr sz="1500" b="0" dirty="0">
+                <a:solidFill>
+                  <a:srgbClr val="212121"/>
+                </a:solidFill>
+                <a:latin typeface="Calibri"/>
+              </a:rPr>
+              <a:t>a state can produce</a:t>
+            </a:r>
+          </a:p>
+          <a:p>
+            <a:pPr>
+              <a:spcAft>
+                <a:spcPts val="1100"/>
+              </a:spcAft>
+            </a:pPr>
+            <a:r>
+              <a:rPr sz="1600" b="0" dirty="0">
+                <a:solidFill>
+                  <a:srgbClr val="1E2761"/>
+                </a:solidFill>
+                <a:latin typeface="Cambria Math"/>
+              </a:rPr>
+              <a:t>k, m, </a:t>
+            </a:r>
+            <a:r>
+              <a:rPr sz="1600" b="0" dirty="0" err="1">
+                <a:solidFill>
+                  <a:srgbClr val="1E2761"/>
+                </a:solidFill>
+                <a:latin typeface="Cambria Math"/>
+              </a:rPr>
+              <a:t>ε</a:t>
+            </a:r>
+            <a:r>
+              <a:rPr sz="1600" b="0" dirty="0">
+                <a:solidFill>
+                  <a:srgbClr val="1E2761"/>
+                </a:solidFill>
+                <a:latin typeface="Cambria Math"/>
+              </a:rPr>
+              <a:t>   </a:t>
+            </a:r>
+            <a:r>
+              <a:rPr sz="1500" b="1" dirty="0">
+                <a:solidFill>
+                  <a:srgbClr val="212121"/>
+                </a:solidFill>
+                <a:latin typeface="Calibri"/>
+              </a:rPr>
+              <a:t>constants </a:t>
+            </a:r>
+            <a:endParaRPr lang="en-US" sz="1500" b="1" dirty="0">
+              <a:solidFill>
+                <a:srgbClr val="212121"/>
+              </a:solidFill>
+              <a:latin typeface="Calibri"/>
+            </a:endParaRPr>
+          </a:p>
+          <a:p>
+            <a:pPr>
+              <a:spcAft>
+                <a:spcPts val="1100"/>
+              </a:spcAft>
+            </a:pPr>
+            <a:r>
+              <a:rPr sz="1600" b="0" dirty="0">
+                <a:solidFill>
+                  <a:srgbClr val="1E2761"/>
+                </a:solidFill>
+                <a:latin typeface="Cambria Math"/>
+              </a:rPr>
+              <a:t>q(u, </a:t>
+            </a:r>
+            <a:r>
+              <a:rPr sz="1600" b="0" dirty="0" err="1">
+                <a:solidFill>
+                  <a:srgbClr val="1E2761"/>
+                </a:solidFill>
+                <a:latin typeface="Cambria Math"/>
+              </a:rPr>
+              <a:t>τ</a:t>
+            </a:r>
+            <a:r>
+              <a:rPr sz="1600" b="0" dirty="0">
+                <a:solidFill>
+                  <a:srgbClr val="1E2761"/>
+                </a:solidFill>
+                <a:latin typeface="Cambria Math"/>
+              </a:rPr>
+              <a:t>)   </a:t>
+            </a:r>
+            <a:r>
+              <a:rPr sz="1500" b="0" dirty="0">
+                <a:solidFill>
+                  <a:srgbClr val="212121"/>
+                </a:solidFill>
+                <a:latin typeface="Calibri"/>
+              </a:rPr>
+              <a:t>plastic fraction of the strain rate</a:t>
+            </a:r>
+            <a:r>
+              <a:rPr lang="en-US" sz="1500" dirty="0">
+                <a:solidFill>
+                  <a:srgbClr val="212121"/>
+                </a:solidFill>
+                <a:latin typeface="Calibri"/>
+              </a:rPr>
+              <a:t>:</a:t>
+            </a:r>
+            <a:r>
+              <a:rPr sz="1500" b="0" dirty="0">
+                <a:solidFill>
+                  <a:srgbClr val="212121"/>
+                </a:solidFill>
+                <a:latin typeface="Calibri"/>
+              </a:rPr>
+              <a:t> 0</a:t>
+            </a:r>
+            <a:r>
+              <a:rPr lang="en-US" sz="1500" b="0" dirty="0">
+                <a:solidFill>
+                  <a:srgbClr val="212121"/>
+                </a:solidFill>
+                <a:latin typeface="Calibri"/>
+              </a:rPr>
+              <a:t>-&gt;</a:t>
+            </a:r>
+            <a:r>
+              <a:rPr sz="1500" b="0" dirty="0">
+                <a:solidFill>
+                  <a:srgbClr val="212121"/>
+                </a:solidFill>
+                <a:latin typeface="Calibri"/>
+              </a:rPr>
+              <a:t>elastic, 1</a:t>
+            </a:r>
+            <a:r>
+              <a:rPr lang="en-US" sz="1500" b="0" dirty="0">
+                <a:solidFill>
+                  <a:srgbClr val="212121"/>
+                </a:solidFill>
+                <a:latin typeface="Calibri"/>
+              </a:rPr>
+              <a:t>-&gt;</a:t>
+            </a:r>
+            <a:r>
+              <a:rPr sz="1500" b="0" dirty="0">
+                <a:solidFill>
+                  <a:srgbClr val="212121"/>
+                </a:solidFill>
+                <a:latin typeface="Calibri"/>
+              </a:rPr>
+              <a:t>steady </a:t>
+            </a:r>
+            <a:r>
+              <a:rPr lang="en-US" sz="1500" b="0" dirty="0">
+                <a:solidFill>
+                  <a:srgbClr val="212121"/>
+                </a:solidFill>
+                <a:latin typeface="Calibri"/>
+              </a:rPr>
+              <a:t>state</a:t>
+            </a:r>
+          </a:p>
+          <a:p>
+            <a:pPr>
+              <a:spcAft>
+                <a:spcPts val="1100"/>
+              </a:spcAft>
+            </a:pPr>
+            <a:r>
+              <a:rPr lang="en-US" sz="1500" dirty="0">
+                <a:solidFill>
+                  <a:srgbClr val="212121"/>
+                </a:solidFill>
+                <a:latin typeface="Calibri"/>
+              </a:rPr>
+              <a:t>	eq.-&gt; </a:t>
+            </a:r>
+            <a:r>
+              <a:rPr lang="en-US" sz="1500" dirty="0">
+                <a:solidFill>
+                  <a:srgbClr val="212121"/>
+                </a:solidFill>
+              </a:rPr>
+              <a:t>q = 1 − (d</a:t>
+            </a:r>
+            <a:r>
+              <a:rPr lang="el-GR" sz="1500" dirty="0">
+                <a:solidFill>
+                  <a:srgbClr val="212121"/>
+                </a:solidFill>
+              </a:rPr>
+              <a:t>τ/</a:t>
+            </a:r>
+            <a:r>
+              <a:rPr lang="en-US" sz="1500" dirty="0">
+                <a:solidFill>
+                  <a:srgbClr val="212121"/>
+                </a:solidFill>
+              </a:rPr>
+              <a:t>d</a:t>
+            </a:r>
+            <a:r>
+              <a:rPr lang="el-GR" sz="1500" dirty="0">
+                <a:solidFill>
+                  <a:srgbClr val="212121"/>
+                </a:solidFill>
+              </a:rPr>
+              <a:t>γ)/2μ</a:t>
+            </a:r>
+            <a:endParaRPr sz="1500" b="0" dirty="0">
+              <a:solidFill>
+                <a:srgbClr val="212121"/>
+              </a:solidFill>
+              <a:latin typeface="Calibri"/>
+            </a:endParaRPr>
+          </a:p>
+          <a:p>
+            <a:pPr>
+              <a:spcAft>
+                <a:spcPts val="1100"/>
+              </a:spcAft>
+            </a:pPr>
+            <a:r>
+              <a:rPr sz="1600" b="0" dirty="0">
+                <a:solidFill>
+                  <a:srgbClr val="1E2761"/>
+                </a:solidFill>
+                <a:latin typeface="Cambria Math"/>
+              </a:rPr>
+              <a:t>aging event   </a:t>
+            </a:r>
+            <a:r>
+              <a:rPr sz="1500" b="0" dirty="0">
+                <a:solidFill>
+                  <a:srgbClr val="212121"/>
+                </a:solidFill>
+                <a:latin typeface="Calibri"/>
+              </a:rPr>
+              <a:t>a step where u drops but </a:t>
+            </a:r>
+            <a:r>
+              <a:rPr sz="1500" b="0" dirty="0" err="1">
+                <a:solidFill>
+                  <a:srgbClr val="212121"/>
+                </a:solidFill>
+                <a:latin typeface="Calibri"/>
+              </a:rPr>
+              <a:t>τ</a:t>
+            </a:r>
+            <a:r>
+              <a:rPr sz="1500" b="0" dirty="0">
+                <a:solidFill>
+                  <a:srgbClr val="212121"/>
+                </a:solidFill>
+                <a:latin typeface="Calibri"/>
+              </a:rPr>
+              <a:t> does not (105,188); it relaxes energy without releasing stress</a:t>
+            </a:r>
+          </a:p>
+        </p:txBody>
+      </p:sp>
+    </p:spTree>
+  </p:cSld>
+  <p:clrMapOvr>
+    <a:masterClrMapping/>
+  </p:clrMapOvr>
+</p:sld>
+</file>
+
+<file path=ppt/slides/slide6.xml><?xml version="1.0" encoding="utf-8"?>
+<p:sld xmlns:a="http://schemas.openxmlformats.org/drawingml/2006/main" xmlns:r="http://schemas.openxmlformats.org/officeDocument/2006/relationships" xmlns:p="http://schemas.openxmlformats.org/presentationml/2006/main">
+  <p:cSld>
+    <p:spTree>
+      <p:nvGrpSpPr>
+        <p:cNvPr id="1" name=""/>
+        <p:cNvGrpSpPr/>
+        <p:nvPr/>
+      </p:nvGrpSpPr>
+      <p:grpSpPr>
+        <a:xfrm>
+          <a:off x="0" y="0"/>
+          <a:ext cx="0" cy="0"/>
+          <a:chOff x="0" y="0"/>
+          <a:chExt cx="0" cy="0"/>
+        </a:xfrm>
+      </p:grpSpPr>
       <p:sp>
         <p:nvSpPr>
           <p:cNvPr id="2" name="TextBox 1"/>
@@ -4062,13 +5011,31 @@
           <a:lstStyle/>
           <a:p>
             <a:r>
-              <a:rPr sz="3000" b="1">
+              <a:rPr sz="3000" b="1" dirty="0">
                 <a:solidFill>
                   <a:srgbClr val="1E2761"/>
                 </a:solidFill>
                 <a:latin typeface="Calibri"/>
               </a:rPr>
-              <a:t>The symbolic-regression library  (library/symreg.py)</a:t>
+              <a:t>The symbolic-regression library  (library/</a:t>
+            </a:r>
+            <a:r>
+              <a:rPr sz="3000" b="1" dirty="0" err="1">
+                <a:solidFill>
+                  <a:srgbClr val="1E2761"/>
+                </a:solidFill>
+                <a:latin typeface="Calibri"/>
+              </a:rPr>
+              <a:t>symreg.py</a:t>
+            </a:r>
+            <a:r>
+              <a:rPr sz="3000" b="1" dirty="0">
+                <a:solidFill>
+                  <a:srgbClr val="1E2761"/>
+                </a:solidFill>
+                <a:latin typeface="Calibri"/>
+              </a:rPr>
+              <a:t>)</a:t>
             </a:r>
           </a:p>
         </p:txBody>
@@ -4511,6 +5478,1465 @@
           </a:p>
         </p:txBody>
       </p:sp>
+    </p:spTree>
+  </p:cSld>
+  <p:clrMapOvr>
+    <a:masterClrMapping/>
+  </p:clrMapOvr>
+</p:sld>
+</file>
+
+<file path=ppt/slides/slide7.xml><?xml version="1.0" encoding="utf-8"?>
+<p:sld xmlns:a="http://schemas.openxmlformats.org/drawingml/2006/main" xmlns:r="http://schemas.openxmlformats.org/officeDocument/2006/relationships" xmlns:p="http://schemas.openxmlformats.org/presentationml/2006/main">
+  <p:cSld>
+    <p:spTree>
+      <p:nvGrpSpPr>
+        <p:cNvPr id="1" name=""/>
+        <p:cNvGrpSpPr/>
+        <p:nvPr/>
+      </p:nvGrpSpPr>
+      <p:grpSpPr>
+        <a:xfrm>
+          <a:off x="0" y="0"/>
+          <a:ext cx="0" cy="0"/>
+          <a:chOff x="0" y="0"/>
+          <a:chExt cx="0" cy="0"/>
+        </a:xfrm>
+      </p:grpSpPr>
+      <p:sp>
+        <p:nvSpPr>
+          <p:cNvPr id="2" name="TextBox 1"/>
+          <p:cNvSpPr txBox="1"/>
+          <p:nvPr/>
+        </p:nvSpPr>
+        <p:spPr>
+          <a:xfrm>
+            <a:off x="548640" y="292608"/>
+            <a:ext cx="11091672" cy="461665"/>
+          </a:xfrm>
+          <a:prstGeom prst="rect">
+            <a:avLst/>
+          </a:prstGeom>
+          <a:noFill/>
+        </p:spPr>
+        <p:txBody>
+          <a:bodyPr wrap="square" lIns="0" tIns="0" rIns="0" bIns="0">
+            <a:spAutoFit/>
+          </a:bodyPr>
+          <a:lstStyle/>
+          <a:p>
+            <a:r>
+              <a:rPr lang="en-US" sz="3000" b="1" dirty="0">
+                <a:solidFill>
+                  <a:srgbClr val="1E2761"/>
+                </a:solidFill>
+                <a:latin typeface="Calibri"/>
+              </a:rPr>
+              <a:t>Symbolic Regression at Each Complexity</a:t>
+            </a:r>
+            <a:endParaRPr sz="3000" b="1" dirty="0">
+              <a:solidFill>
+                <a:srgbClr val="1E2761"/>
+              </a:solidFill>
+              <a:latin typeface="Calibri"/>
+            </a:endParaRPr>
+          </a:p>
+        </p:txBody>
+      </p:sp>
+      <p:graphicFrame>
+        <p:nvGraphicFramePr>
+          <p:cNvPr id="4" name="Table 3"/>
+          <p:cNvGraphicFramePr>
+            <a:graphicFrameLocks noGrp="1"/>
+          </p:cNvGraphicFramePr>
+          <p:nvPr>
+            <p:extLst>
+              <p:ext uri="{D42A27DB-BD31-4B8C-83A1-F6EECF244321}">
+                <p14:modId xmlns:p14="http://schemas.microsoft.com/office/powerpoint/2010/main" val="517392100"/>
+              </p:ext>
+            </p:extLst>
+          </p:nvPr>
+        </p:nvGraphicFramePr>
+        <p:xfrm>
+          <a:off x="640080" y="1245816"/>
+          <a:ext cx="11091672" cy="2788920"/>
+        </p:xfrm>
+        <a:graphic>
+          <a:graphicData uri="http://schemas.openxmlformats.org/drawingml/2006/table">
+            <a:tbl>
+              <a:tblPr firstRow="1">
+                <a:tableStyleId>{5C22544A-7EE6-4342-B048-85BDC9FD1C3A}</a:tableStyleId>
+              </a:tblPr>
+              <a:tblGrid>
+                <a:gridCol w="932073">
+                  <a:extLst>
+                    <a:ext uri="{9D8B030D-6E8A-4147-A177-3AD203B41FA5}">
+                      <a16:colId xmlns:a16="http://schemas.microsoft.com/office/drawing/2014/main" val="20000"/>
+                    </a:ext>
+                  </a:extLst>
+                </a:gridCol>
+                <a:gridCol w="3355464">
+                  <a:extLst>
+                    <a:ext uri="{9D8B030D-6E8A-4147-A177-3AD203B41FA5}">
+                      <a16:colId xmlns:a16="http://schemas.microsoft.com/office/drawing/2014/main" val="20001"/>
+                    </a:ext>
+                  </a:extLst>
+                </a:gridCol>
+                <a:gridCol w="932073">
+                  <a:extLst>
+                    <a:ext uri="{9D8B030D-6E8A-4147-A177-3AD203B41FA5}">
+                      <a16:colId xmlns:a16="http://schemas.microsoft.com/office/drawing/2014/main" val="20002"/>
+                    </a:ext>
+                  </a:extLst>
+                </a:gridCol>
+                <a:gridCol w="5872062">
+                  <a:extLst>
+                    <a:ext uri="{9D8B030D-6E8A-4147-A177-3AD203B41FA5}">
+                      <a16:colId xmlns:a16="http://schemas.microsoft.com/office/drawing/2014/main" val="20003"/>
+                    </a:ext>
+                  </a:extLst>
+                </a:gridCol>
+              </a:tblGrid>
+              <a:tr h="348615">
+                <a:tc>
+                  <a:txBody>
+                    <a:bodyPr/>
+                    <a:lstStyle/>
+                    <a:p>
+                      <a:r>
+                        <a:rPr sz="1300" b="1">
+                          <a:solidFill>
+                            <a:srgbClr val="FFFFFF"/>
+                          </a:solidFill>
+                          <a:latin typeface="Calibri"/>
+                        </a:rPr>
+                        <a:t>budget</a:t>
+                      </a:r>
+                    </a:p>
+                  </a:txBody>
+                  <a:tcPr marL="73152" marR="54864" marT="27432" marB="27432" anchor="ctr">
+                    <a:solidFill>
+                      <a:srgbClr val="1E2761"/>
+                    </a:solidFill>
+                  </a:tcPr>
+                </a:tc>
+                <a:tc>
+                  <a:txBody>
+                    <a:bodyPr/>
+                    <a:lstStyle/>
+                    <a:p>
+                      <a:r>
+                        <a:rPr sz="1300" b="1">
+                          <a:solidFill>
+                            <a:srgbClr val="FFFFFF"/>
+                          </a:solidFill>
+                          <a:latin typeface="Calibri"/>
+                        </a:rPr>
+                        <a:t>form found</a:t>
+                      </a:r>
+                    </a:p>
+                  </a:txBody>
+                  <a:tcPr marL="73152" marR="54864" marT="27432" marB="27432" anchor="ctr">
+                    <a:solidFill>
+                      <a:srgbClr val="1E2761"/>
+                    </a:solidFill>
+                  </a:tcPr>
+                </a:tc>
+                <a:tc>
+                  <a:txBody>
+                    <a:bodyPr/>
+                    <a:lstStyle/>
+                    <a:p>
+                      <a:r>
+                        <a:rPr sz="1300" b="1">
+                          <a:solidFill>
+                            <a:srgbClr val="FFFFFF"/>
+                          </a:solidFill>
+                          <a:latin typeface="Calibri"/>
+                        </a:rPr>
+                        <a:t>misfit</a:t>
+                      </a:r>
+                    </a:p>
+                  </a:txBody>
+                  <a:tcPr marL="73152" marR="54864" marT="27432" marB="27432" anchor="ctr">
+                    <a:solidFill>
+                      <a:srgbClr val="1E2761"/>
+                    </a:solidFill>
+                  </a:tcPr>
+                </a:tc>
+                <a:tc>
+                  <a:txBody>
+                    <a:bodyPr/>
+                    <a:lstStyle/>
+                    <a:p>
+                      <a:r>
+                        <a:rPr sz="1300" b="1">
+                          <a:solidFill>
+                            <a:srgbClr val="FFFFFF"/>
+                          </a:solidFill>
+                          <a:latin typeface="Calibri"/>
+                        </a:rPr>
+                        <a:t>what it is</a:t>
+                      </a:r>
+                    </a:p>
+                  </a:txBody>
+                  <a:tcPr marL="73152" marR="54864" marT="27432" marB="27432" anchor="ctr">
+                    <a:solidFill>
+                      <a:srgbClr val="1E2761"/>
+                    </a:solidFill>
+                  </a:tcPr>
+                </a:tc>
+                <a:extLst>
+                  <a:ext uri="{0D108BD9-81ED-4DB2-BD59-A6C34878D82A}">
+                    <a16:rowId xmlns:a16="http://schemas.microsoft.com/office/drawing/2014/main" val="10000"/>
+                  </a:ext>
+                </a:extLst>
+              </a:tr>
+              <a:tr h="348615">
+                <a:tc>
+                  <a:txBody>
+                    <a:bodyPr/>
+                    <a:lstStyle/>
+                    <a:p>
+                      <a:r>
+                        <a:rPr sz="1300" b="0">
+                          <a:solidFill>
+                            <a:srgbClr val="212121"/>
+                          </a:solidFill>
+                          <a:latin typeface="Calibri"/>
+                        </a:rPr>
+                        <a:t>1</a:t>
+                      </a:r>
+                    </a:p>
+                  </a:txBody>
+                  <a:tcPr marL="73152" marR="54864" marT="27432" marB="27432" anchor="ctr">
+                    <a:solidFill>
+                      <a:srgbClr val="FFFFFF"/>
+                    </a:solidFill>
+                  </a:tcPr>
+                </a:tc>
+                <a:tc>
+                  <a:txBody>
+                    <a:bodyPr/>
+                    <a:lstStyle/>
+                    <a:p>
+                      <a:r>
+                        <a:rPr sz="1400" b="0">
+                          <a:solidFill>
+                            <a:srgbClr val="1E2761"/>
+                          </a:solidFill>
+                          <a:latin typeface="Cambria Math"/>
+                        </a:rPr>
+                        <a:t>s</a:t>
+                      </a:r>
+                    </a:p>
+                  </a:txBody>
+                  <a:tcPr marL="73152" marR="54864" marT="27432" marB="27432" anchor="ctr">
+                    <a:solidFill>
+                      <a:srgbClr val="FFFFFF"/>
+                    </a:solidFill>
+                  </a:tcPr>
+                </a:tc>
+                <a:tc>
+                  <a:txBody>
+                    <a:bodyPr/>
+                    <a:lstStyle/>
+                    <a:p>
+                      <a:r>
+                        <a:rPr sz="1300" b="0">
+                          <a:solidFill>
+                            <a:srgbClr val="212121"/>
+                          </a:solidFill>
+                          <a:latin typeface="Calibri"/>
+                        </a:rPr>
+                        <a:t>1.22</a:t>
+                      </a:r>
+                    </a:p>
+                  </a:txBody>
+                  <a:tcPr marL="73152" marR="54864" marT="27432" marB="27432" anchor="ctr">
+                    <a:solidFill>
+                      <a:srgbClr val="FFFFFF"/>
+                    </a:solidFill>
+                  </a:tcPr>
+                </a:tc>
+                <a:tc>
+                  <a:txBody>
+                    <a:bodyPr/>
+                    <a:lstStyle/>
+                    <a:p>
+                      <a:r>
+                        <a:rPr sz="1300" b="0">
+                          <a:solidFill>
+                            <a:srgbClr val="212121"/>
+                          </a:solidFill>
+                          <a:latin typeface="Calibri"/>
+                        </a:rPr>
+                        <a:t>a straight line</a:t>
+                      </a:r>
+                    </a:p>
+                  </a:txBody>
+                  <a:tcPr marL="73152" marR="54864" marT="27432" marB="27432" anchor="ctr">
+                    <a:solidFill>
+                      <a:srgbClr val="FFFFFF"/>
+                    </a:solidFill>
+                  </a:tcPr>
+                </a:tc>
+                <a:extLst>
+                  <a:ext uri="{0D108BD9-81ED-4DB2-BD59-A6C34878D82A}">
+                    <a16:rowId xmlns:a16="http://schemas.microsoft.com/office/drawing/2014/main" val="10001"/>
+                  </a:ext>
+                </a:extLst>
+              </a:tr>
+              <a:tr h="348615">
+                <a:tc>
+                  <a:txBody>
+                    <a:bodyPr/>
+                    <a:lstStyle/>
+                    <a:p>
+                      <a:r>
+                        <a:rPr sz="1300" b="0">
+                          <a:solidFill>
+                            <a:srgbClr val="212121"/>
+                          </a:solidFill>
+                          <a:latin typeface="Calibri"/>
+                        </a:rPr>
+                        <a:t>3</a:t>
+                      </a:r>
+                    </a:p>
+                  </a:txBody>
+                  <a:tcPr marL="73152" marR="54864" marT="27432" marB="27432" anchor="ctr">
+                    <a:solidFill>
+                      <a:srgbClr val="FFFFFF"/>
+                    </a:solidFill>
+                  </a:tcPr>
+                </a:tc>
+                <a:tc>
+                  <a:txBody>
+                    <a:bodyPr/>
+                    <a:lstStyle/>
+                    <a:p>
+                      <a:r>
+                        <a:rPr sz="1400" b="0">
+                          <a:solidFill>
+                            <a:srgbClr val="1E2761"/>
+                          </a:solidFill>
+                          <a:latin typeface="Cambria Math"/>
+                        </a:rPr>
+                        <a:t>log s</a:t>
+                      </a:r>
+                    </a:p>
+                  </a:txBody>
+                  <a:tcPr marL="73152" marR="54864" marT="27432" marB="27432" anchor="ctr">
+                    <a:solidFill>
+                      <a:srgbClr val="FFFFFF"/>
+                    </a:solidFill>
+                  </a:tcPr>
+                </a:tc>
+                <a:tc>
+                  <a:txBody>
+                    <a:bodyPr/>
+                    <a:lstStyle/>
+                    <a:p>
+                      <a:r>
+                        <a:rPr sz="1300" b="0">
+                          <a:solidFill>
+                            <a:srgbClr val="212121"/>
+                          </a:solidFill>
+                          <a:latin typeface="Calibri"/>
+                        </a:rPr>
+                        <a:t>0.30</a:t>
+                      </a:r>
+                    </a:p>
+                  </a:txBody>
+                  <a:tcPr marL="73152" marR="54864" marT="27432" marB="27432" anchor="ctr">
+                    <a:solidFill>
+                      <a:srgbClr val="FFFFFF"/>
+                    </a:solidFill>
+                  </a:tcPr>
+                </a:tc>
+                <a:tc>
+                  <a:txBody>
+                    <a:bodyPr/>
+                    <a:lstStyle/>
+                    <a:p>
+                      <a:r>
+                        <a:rPr sz="1300" b="0" dirty="0">
+                          <a:solidFill>
+                            <a:srgbClr val="212121"/>
+                          </a:solidFill>
+                          <a:latin typeface="Calibri"/>
+                        </a:rPr>
+                        <a:t>pure power law, </a:t>
+                      </a:r>
+                      <a:r>
+                        <a:rPr sz="1300" b="0" dirty="0" err="1">
+                          <a:solidFill>
+                            <a:srgbClr val="212121"/>
+                          </a:solidFill>
+                          <a:latin typeface="Calibri"/>
+                        </a:rPr>
+                        <a:t>ρ</a:t>
+                      </a:r>
+                      <a:r>
+                        <a:rPr sz="1300" b="0" dirty="0">
+                          <a:solidFill>
+                            <a:srgbClr val="212121"/>
+                          </a:solidFill>
+                          <a:latin typeface="Calibri"/>
+                        </a:rPr>
+                        <a:t> ∝ s⁻ᵏ</a:t>
+                      </a:r>
+                    </a:p>
+                  </a:txBody>
+                  <a:tcPr marL="73152" marR="54864" marT="27432" marB="27432" anchor="ctr">
+                    <a:solidFill>
+                      <a:srgbClr val="FFFFFF"/>
+                    </a:solidFill>
+                  </a:tcPr>
+                </a:tc>
+                <a:extLst>
+                  <a:ext uri="{0D108BD9-81ED-4DB2-BD59-A6C34878D82A}">
+                    <a16:rowId xmlns:a16="http://schemas.microsoft.com/office/drawing/2014/main" val="10002"/>
+                  </a:ext>
+                </a:extLst>
+              </a:tr>
+              <a:tr h="348615">
+                <a:tc>
+                  <a:txBody>
+                    <a:bodyPr/>
+                    <a:lstStyle/>
+                    <a:p>
+                      <a:r>
+                        <a:rPr sz="1300" b="0">
+                          <a:solidFill>
+                            <a:srgbClr val="212121"/>
+                          </a:solidFill>
+                          <a:latin typeface="Calibri"/>
+                        </a:rPr>
+                        <a:t>5</a:t>
+                      </a:r>
+                    </a:p>
+                  </a:txBody>
+                  <a:tcPr marL="73152" marR="54864" marT="27432" marB="27432" anchor="ctr">
+                    <a:solidFill>
+                      <a:srgbClr val="FFFFFF"/>
+                    </a:solidFill>
+                  </a:tcPr>
+                </a:tc>
+                <a:tc>
+                  <a:txBody>
+                    <a:bodyPr/>
+                    <a:lstStyle/>
+                    <a:p>
+                      <a:r>
+                        <a:rPr sz="1400" b="0">
+                          <a:solidFill>
+                            <a:srgbClr val="1E2761"/>
+                          </a:solidFill>
+                          <a:latin typeface="Cambria Math"/>
+                        </a:rPr>
+                        <a:t>log(s + 4.6×10⁻⁴)</a:t>
+                      </a:r>
+                    </a:p>
+                  </a:txBody>
+                  <a:tcPr marL="73152" marR="54864" marT="27432" marB="27432" anchor="ctr">
+                    <a:solidFill>
+                      <a:srgbClr val="FFFFFF"/>
+                    </a:solidFill>
+                  </a:tcPr>
+                </a:tc>
+                <a:tc>
+                  <a:txBody>
+                    <a:bodyPr/>
+                    <a:lstStyle/>
+                    <a:p>
+                      <a:r>
+                        <a:rPr sz="1300" b="0">
+                          <a:solidFill>
+                            <a:srgbClr val="212121"/>
+                          </a:solidFill>
+                          <a:latin typeface="Calibri"/>
+                        </a:rPr>
+                        <a:t>0.21</a:t>
+                      </a:r>
+                    </a:p>
+                  </a:txBody>
+                  <a:tcPr marL="73152" marR="54864" marT="27432" marB="27432" anchor="ctr">
+                    <a:solidFill>
+                      <a:srgbClr val="FFFFFF"/>
+                    </a:solidFill>
+                  </a:tcPr>
+                </a:tc>
+                <a:tc>
+                  <a:txBody>
+                    <a:bodyPr/>
+                    <a:lstStyle/>
+                    <a:p>
+                      <a:r>
+                        <a:rPr sz="1300" b="0" dirty="0">
+                          <a:solidFill>
+                            <a:srgbClr val="212121"/>
+                          </a:solidFill>
+                          <a:latin typeface="Calibri"/>
+                        </a:rPr>
+                        <a:t>power law rounded off at small s</a:t>
+                      </a:r>
+                    </a:p>
+                  </a:txBody>
+                  <a:tcPr marL="73152" marR="54864" marT="27432" marB="27432" anchor="ctr">
+                    <a:solidFill>
+                      <a:srgbClr val="FFFFFF"/>
+                    </a:solidFill>
+                  </a:tcPr>
+                </a:tc>
+                <a:extLst>
+                  <a:ext uri="{0D108BD9-81ED-4DB2-BD59-A6C34878D82A}">
+                    <a16:rowId xmlns:a16="http://schemas.microsoft.com/office/drawing/2014/main" val="10003"/>
+                  </a:ext>
+                </a:extLst>
+              </a:tr>
+              <a:tr h="348615">
+                <a:tc>
+                  <a:txBody>
+                    <a:bodyPr/>
+                    <a:lstStyle/>
+                    <a:p>
+                      <a:r>
+                        <a:rPr sz="1300" b="0">
+                          <a:solidFill>
+                            <a:srgbClr val="212121"/>
+                          </a:solidFill>
+                          <a:latin typeface="Calibri"/>
+                        </a:rPr>
+                        <a:t>6</a:t>
+                      </a:r>
+                    </a:p>
+                  </a:txBody>
+                  <a:tcPr marL="73152" marR="54864" marT="27432" marB="27432" anchor="ctr">
+                    <a:solidFill>
+                      <a:srgbClr val="FFFFFF"/>
+                    </a:solidFill>
+                  </a:tcPr>
+                </a:tc>
+                <a:tc>
+                  <a:txBody>
+                    <a:bodyPr/>
+                    <a:lstStyle/>
+                    <a:p>
+                      <a:r>
+                        <a:rPr sz="1400" b="0">
+                          <a:solidFill>
+                            <a:srgbClr val="1E2761"/>
+                          </a:solidFill>
+                          <a:latin typeface="Cambria Math"/>
+                        </a:rPr>
+                        <a:t>√log(1/s)</a:t>
+                      </a:r>
+                    </a:p>
+                  </a:txBody>
+                  <a:tcPr marL="73152" marR="54864" marT="27432" marB="27432" anchor="ctr">
+                    <a:solidFill>
+                      <a:srgbClr val="FFFFFF"/>
+                    </a:solidFill>
+                  </a:tcPr>
+                </a:tc>
+                <a:tc>
+                  <a:txBody>
+                    <a:bodyPr/>
+                    <a:lstStyle/>
+                    <a:p>
+                      <a:r>
+                        <a:rPr sz="1300" b="0">
+                          <a:solidFill>
+                            <a:srgbClr val="212121"/>
+                          </a:solidFill>
+                          <a:latin typeface="Calibri"/>
+                        </a:rPr>
+                        <a:t>0.143</a:t>
+                      </a:r>
+                    </a:p>
+                  </a:txBody>
+                  <a:tcPr marL="73152" marR="54864" marT="27432" marB="27432" anchor="ctr">
+                    <a:solidFill>
+                      <a:srgbClr val="FFFFFF"/>
+                    </a:solidFill>
+                  </a:tcPr>
+                </a:tc>
+                <a:tc>
+                  <a:txBody>
+                    <a:bodyPr/>
+                    <a:lstStyle/>
+                    <a:p>
+                      <a:r>
+                        <a:rPr sz="1300" b="0" dirty="0">
+                          <a:solidFill>
+                            <a:srgbClr val="212121"/>
+                          </a:solidFill>
+                          <a:latin typeface="Calibri"/>
+                        </a:rPr>
+                        <a:t>fails the likelihood test (ΔAIC ≈ +20,000)</a:t>
+                      </a:r>
+                      <a:r>
+                        <a:rPr lang="en-US" sz="1300" b="0" dirty="0">
+                          <a:solidFill>
+                            <a:srgbClr val="212121"/>
+                          </a:solidFill>
+                          <a:latin typeface="+mn-lt"/>
+                        </a:rPr>
+                        <a:t> [Akaike information criterion, for next time]</a:t>
+                      </a:r>
+                      <a:endParaRPr sz="1300" b="0" dirty="0">
+                        <a:solidFill>
+                          <a:srgbClr val="212121"/>
+                        </a:solidFill>
+                        <a:latin typeface="Calibri"/>
+                      </a:endParaRPr>
+                    </a:p>
+                  </a:txBody>
+                  <a:tcPr marL="73152" marR="54864" marT="27432" marB="27432" anchor="ctr">
+                    <a:solidFill>
+                      <a:srgbClr val="FFFFFF"/>
+                    </a:solidFill>
+                  </a:tcPr>
+                </a:tc>
+                <a:extLst>
+                  <a:ext uri="{0D108BD9-81ED-4DB2-BD59-A6C34878D82A}">
+                    <a16:rowId xmlns:a16="http://schemas.microsoft.com/office/drawing/2014/main" val="10004"/>
+                  </a:ext>
+                </a:extLst>
+              </a:tr>
+              <a:tr h="348615">
+                <a:tc>
+                  <a:txBody>
+                    <a:bodyPr/>
+                    <a:lstStyle/>
+                    <a:p>
+                      <a:r>
+                        <a:rPr sz="1300" b="0">
+                          <a:solidFill>
+                            <a:srgbClr val="212121"/>
+                          </a:solidFill>
+                          <a:latin typeface="Calibri"/>
+                        </a:rPr>
+                        <a:t>7</a:t>
+                      </a:r>
+                    </a:p>
+                  </a:txBody>
+                  <a:tcPr marL="73152" marR="54864" marT="27432" marB="27432" anchor="ctr">
+                    <a:solidFill>
+                      <a:srgbClr val="FFFFFF"/>
+                    </a:solidFill>
+                  </a:tcPr>
+                </a:tc>
+                <a:tc>
+                  <a:txBody>
+                    <a:bodyPr/>
+                    <a:lstStyle/>
+                    <a:p>
+                      <a:r>
+                        <a:rPr sz="1400" b="0">
+                          <a:solidFill>
+                            <a:srgbClr val="1E2761"/>
+                          </a:solidFill>
+                          <a:latin typeface="Cambria Math"/>
+                        </a:rPr>
+                        <a:t>√log(0.79/s)</a:t>
+                      </a:r>
+                    </a:p>
+                  </a:txBody>
+                  <a:tcPr marL="73152" marR="54864" marT="27432" marB="27432" anchor="ctr">
+                    <a:solidFill>
+                      <a:srgbClr val="FFFFFF"/>
+                    </a:solidFill>
+                  </a:tcPr>
+                </a:tc>
+                <a:tc>
+                  <a:txBody>
+                    <a:bodyPr/>
+                    <a:lstStyle/>
+                    <a:p>
+                      <a:r>
+                        <a:rPr sz="1300" b="0">
+                          <a:solidFill>
+                            <a:srgbClr val="212121"/>
+                          </a:solidFill>
+                          <a:latin typeface="Calibri"/>
+                        </a:rPr>
+                        <a:t>0.142</a:t>
+                      </a:r>
+                    </a:p>
+                  </a:txBody>
+                  <a:tcPr marL="73152" marR="54864" marT="27432" marB="27432" anchor="ctr">
+                    <a:solidFill>
+                      <a:srgbClr val="FFFFFF"/>
+                    </a:solidFill>
+                  </a:tcPr>
+                </a:tc>
+                <a:tc>
+                  <a:txBody>
+                    <a:bodyPr/>
+                    <a:lstStyle/>
+                    <a:p>
+                      <a:r>
+                        <a:rPr sz="1300" b="0" dirty="0">
+                          <a:solidFill>
+                            <a:srgbClr val="212121"/>
+                          </a:solidFill>
+                          <a:latin typeface="Calibri"/>
+                        </a:rPr>
+                        <a:t>same </a:t>
+                      </a:r>
+                      <a:r>
+                        <a:rPr lang="en-US" sz="1300" b="0" dirty="0">
+                          <a:solidFill>
+                            <a:srgbClr val="212121"/>
+                          </a:solidFill>
+                          <a:latin typeface="Calibri"/>
+                        </a:rPr>
+                        <a:t>as above</a:t>
+                      </a:r>
+                      <a:endParaRPr sz="1300" b="0" dirty="0">
+                        <a:solidFill>
+                          <a:srgbClr val="212121"/>
+                        </a:solidFill>
+                        <a:latin typeface="Calibri"/>
+                      </a:endParaRPr>
+                    </a:p>
+                  </a:txBody>
+                  <a:tcPr marL="73152" marR="54864" marT="27432" marB="27432" anchor="ctr">
+                    <a:solidFill>
+                      <a:srgbClr val="FFFFFF"/>
+                    </a:solidFill>
+                  </a:tcPr>
+                </a:tc>
+                <a:extLst>
+                  <a:ext uri="{0D108BD9-81ED-4DB2-BD59-A6C34878D82A}">
+                    <a16:rowId xmlns:a16="http://schemas.microsoft.com/office/drawing/2014/main" val="10005"/>
+                  </a:ext>
+                </a:extLst>
+              </a:tr>
+              <a:tr h="348615">
+                <a:tc>
+                  <a:txBody>
+                    <a:bodyPr/>
+                    <a:lstStyle/>
+                    <a:p>
+                      <a:r>
+                        <a:rPr sz="1300" b="0">
+                          <a:solidFill>
+                            <a:srgbClr val="212121"/>
+                          </a:solidFill>
+                          <a:latin typeface="Calibri"/>
+                        </a:rPr>
+                        <a:t>8</a:t>
+                      </a:r>
+                    </a:p>
+                  </a:txBody>
+                  <a:tcPr marL="73152" marR="54864" marT="27432" marB="27432" anchor="ctr">
+                    <a:solidFill>
+                      <a:srgbClr val="FFFFFF"/>
+                    </a:solidFill>
+                  </a:tcPr>
+                </a:tc>
+                <a:tc>
+                  <a:txBody>
+                    <a:bodyPr/>
+                    <a:lstStyle/>
+                    <a:p>
+                      <a:r>
+                        <a:rPr sz="1400" b="0">
+                          <a:solidFill>
+                            <a:srgbClr val="1E2761"/>
+                          </a:solidFill>
+                          <a:latin typeface="Cambria Math"/>
+                        </a:rPr>
+                        <a:t>log(1/(s + 1.6×10⁻⁴) − 2.25)</a:t>
+                      </a:r>
+                    </a:p>
+                  </a:txBody>
+                  <a:tcPr marL="73152" marR="54864" marT="27432" marB="27432" anchor="ctr">
+                    <a:solidFill>
+                      <a:srgbClr val="FFFFFF"/>
+                    </a:solidFill>
+                  </a:tcPr>
+                </a:tc>
+                <a:tc>
+                  <a:txBody>
+                    <a:bodyPr/>
+                    <a:lstStyle/>
+                    <a:p>
+                      <a:r>
+                        <a:rPr sz="1300" b="0">
+                          <a:solidFill>
+                            <a:srgbClr val="212121"/>
+                          </a:solidFill>
+                          <a:latin typeface="Calibri"/>
+                        </a:rPr>
+                        <a:t>0.118</a:t>
+                      </a:r>
+                    </a:p>
+                  </a:txBody>
+                  <a:tcPr marL="73152" marR="54864" marT="27432" marB="27432" anchor="ctr">
+                    <a:solidFill>
+                      <a:srgbClr val="FFFFFF"/>
+                    </a:solidFill>
+                  </a:tcPr>
+                </a:tc>
+                <a:tc>
+                  <a:txBody>
+                    <a:bodyPr/>
+                    <a:lstStyle/>
+                    <a:p>
+                      <a:r>
+                        <a:rPr sz="1300" b="0">
+                          <a:solidFill>
+                            <a:srgbClr val="212121"/>
+                          </a:solidFill>
+                          <a:latin typeface="Calibri"/>
+                        </a:rPr>
+                        <a:t>the ceiling law (below)</a:t>
+                      </a:r>
+                    </a:p>
+                  </a:txBody>
+                  <a:tcPr marL="73152" marR="54864" marT="27432" marB="27432" anchor="ctr">
+                    <a:solidFill>
+                      <a:srgbClr val="FFFFFF"/>
+                    </a:solidFill>
+                  </a:tcPr>
+                </a:tc>
+                <a:extLst>
+                  <a:ext uri="{0D108BD9-81ED-4DB2-BD59-A6C34878D82A}">
+                    <a16:rowId xmlns:a16="http://schemas.microsoft.com/office/drawing/2014/main" val="10006"/>
+                  </a:ext>
+                </a:extLst>
+              </a:tr>
+              <a:tr h="348615">
+                <a:tc>
+                  <a:txBody>
+                    <a:bodyPr/>
+                    <a:lstStyle/>
+                    <a:p>
+                      <a:r>
+                        <a:rPr sz="1300" b="0">
+                          <a:solidFill>
+                            <a:srgbClr val="212121"/>
+                          </a:solidFill>
+                          <a:latin typeface="Calibri"/>
+                        </a:rPr>
+                        <a:t>9</a:t>
+                      </a:r>
+                    </a:p>
+                  </a:txBody>
+                  <a:tcPr marL="73152" marR="54864" marT="27432" marB="27432" anchor="ctr">
+                    <a:solidFill>
+                      <a:srgbClr val="FFFFFF"/>
+                    </a:solidFill>
+                  </a:tcPr>
+                </a:tc>
+                <a:tc>
+                  <a:txBody>
+                    <a:bodyPr/>
+                    <a:lstStyle/>
+                    <a:p>
+                      <a:r>
+                        <a:rPr sz="1400" b="0">
+                          <a:solidFill>
+                            <a:srgbClr val="1E2761"/>
+                          </a:solidFill>
+                          <a:latin typeface="Cambria Math"/>
+                        </a:rPr>
+                        <a:t>s + √(−0.93 − log s)</a:t>
+                      </a:r>
+                    </a:p>
+                  </a:txBody>
+                  <a:tcPr marL="73152" marR="54864" marT="27432" marB="27432" anchor="ctr">
+                    <a:solidFill>
+                      <a:srgbClr val="FFFFFF"/>
+                    </a:solidFill>
+                  </a:tcPr>
+                </a:tc>
+                <a:tc>
+                  <a:txBody>
+                    <a:bodyPr/>
+                    <a:lstStyle/>
+                    <a:p>
+                      <a:r>
+                        <a:rPr sz="1300" b="0">
+                          <a:solidFill>
+                            <a:srgbClr val="212121"/>
+                          </a:solidFill>
+                          <a:latin typeface="Calibri"/>
+                        </a:rPr>
+                        <a:t>0.103</a:t>
+                      </a:r>
+                    </a:p>
+                  </a:txBody>
+                  <a:tcPr marL="73152" marR="54864" marT="27432" marB="27432" anchor="ctr">
+                    <a:solidFill>
+                      <a:srgbClr val="FFFFFF"/>
+                    </a:solidFill>
+                  </a:tcPr>
+                </a:tc>
+                <a:tc>
+                  <a:txBody>
+                    <a:bodyPr/>
+                    <a:lstStyle/>
+                    <a:p>
+                      <a:r>
+                        <a:rPr lang="en-US" sz="1300" b="0" dirty="0">
+                          <a:solidFill>
+                            <a:srgbClr val="212121"/>
+                          </a:solidFill>
+                          <a:latin typeface="Calibri"/>
+                        </a:rPr>
+                        <a:t>same as earlier</a:t>
+                      </a:r>
+                      <a:r>
+                        <a:rPr sz="1300" b="0" dirty="0">
+                          <a:solidFill>
+                            <a:srgbClr val="212121"/>
+                          </a:solidFill>
+                          <a:latin typeface="Calibri"/>
+                        </a:rPr>
+                        <a:t>, </a:t>
+                      </a:r>
+                      <a:r>
+                        <a:rPr lang="en-US" sz="1300" b="0" dirty="0">
+                          <a:solidFill>
+                            <a:srgbClr val="212121"/>
+                          </a:solidFill>
+                          <a:latin typeface="Calibri"/>
+                        </a:rPr>
+                        <a:t>now </a:t>
+                      </a:r>
+                      <a:r>
+                        <a:rPr sz="1300" b="0" dirty="0">
+                          <a:solidFill>
+                            <a:srgbClr val="212121"/>
+                          </a:solidFill>
+                          <a:latin typeface="Calibri"/>
+                        </a:rPr>
+                        <a:t>with a</a:t>
+                      </a:r>
+                      <a:r>
+                        <a:rPr lang="en-US" sz="1300" b="0" dirty="0">
+                          <a:solidFill>
+                            <a:srgbClr val="212121"/>
+                          </a:solidFill>
+                          <a:latin typeface="Calibri"/>
+                        </a:rPr>
+                        <a:t>nother </a:t>
+                      </a:r>
+                      <a:r>
+                        <a:rPr sz="1300" b="0" dirty="0">
+                          <a:solidFill>
+                            <a:srgbClr val="212121"/>
+                          </a:solidFill>
+                          <a:latin typeface="Calibri"/>
+                        </a:rPr>
+                        <a:t>term; still loses under likelihood</a:t>
+                      </a:r>
+                    </a:p>
+                  </a:txBody>
+                  <a:tcPr marL="73152" marR="54864" marT="27432" marB="27432" anchor="ctr">
+                    <a:solidFill>
+                      <a:srgbClr val="FFFFFF"/>
+                    </a:solidFill>
+                  </a:tcPr>
+                </a:tc>
+                <a:extLst>
+                  <a:ext uri="{0D108BD9-81ED-4DB2-BD59-A6C34878D82A}">
+                    <a16:rowId xmlns:a16="http://schemas.microsoft.com/office/drawing/2014/main" val="10007"/>
+                  </a:ext>
+                </a:extLst>
+              </a:tr>
+            </a:tbl>
+          </a:graphicData>
+        </a:graphic>
+      </p:graphicFrame>
+      <p:sp>
+        <p:nvSpPr>
+          <p:cNvPr id="5" name="TextBox 4"/>
+          <p:cNvSpPr txBox="1"/>
+          <p:nvPr/>
+        </p:nvSpPr>
+        <p:spPr>
+          <a:xfrm>
+            <a:off x="640080" y="4526280"/>
+            <a:ext cx="10972800" cy="1737360"/>
+          </a:xfrm>
+          <a:prstGeom prst="rect">
+            <a:avLst/>
+          </a:prstGeom>
+          <a:noFill/>
+        </p:spPr>
+        <p:txBody>
+          <a:bodyPr wrap="square" lIns="0" tIns="0" rIns="0" bIns="0">
+            <a:spAutoFit/>
+          </a:bodyPr>
+          <a:lstStyle/>
+          <a:p>
+            <a:pPr>
+              <a:spcAft>
+                <a:spcPts val="600"/>
+              </a:spcAft>
+            </a:pPr>
+            <a:r>
+              <a:rPr sz="1600" b="1" dirty="0">
+                <a:solidFill>
+                  <a:srgbClr val="1E2761"/>
+                </a:solidFill>
+                <a:latin typeface="Calibri"/>
+              </a:rPr>
+              <a:t>How the complexity-8 form becomes the law</a:t>
+            </a:r>
+          </a:p>
+          <a:p>
+            <a:pPr marL="228600" indent="-228600">
+              <a:spcAft>
+                <a:spcPts val="800"/>
+              </a:spcAft>
+              <a:buChar char="•"/>
+            </a:pPr>
+            <a:r>
+              <a:rPr sz="1400" b="0" dirty="0">
+                <a:solidFill>
+                  <a:srgbClr val="212121"/>
+                </a:solidFill>
+                <a:latin typeface="Calibri"/>
+              </a:rPr>
+              <a:t>The fit is ln </a:t>
+            </a:r>
+            <a:r>
+              <a:rPr sz="1400" b="0" dirty="0" err="1">
+                <a:solidFill>
+                  <a:srgbClr val="212121"/>
+                </a:solidFill>
+                <a:latin typeface="Calibri"/>
+              </a:rPr>
+              <a:t>ρ</a:t>
+            </a:r>
+            <a:r>
+              <a:rPr sz="1400" b="0" dirty="0">
+                <a:solidFill>
+                  <a:srgbClr val="212121"/>
+                </a:solidFill>
+                <a:latin typeface="Calibri"/>
+              </a:rPr>
+              <a:t> = </a:t>
+            </a:r>
+            <a:r>
+              <a:rPr sz="1400" b="0" dirty="0" err="1">
+                <a:solidFill>
+                  <a:srgbClr val="212121"/>
+                </a:solidFill>
+                <a:latin typeface="Calibri"/>
+              </a:rPr>
+              <a:t>a·f</a:t>
+            </a:r>
+            <a:r>
+              <a:rPr sz="1400" b="0" dirty="0">
+                <a:solidFill>
+                  <a:srgbClr val="212121"/>
+                </a:solidFill>
+                <a:latin typeface="Calibri"/>
+              </a:rPr>
+              <a:t>(s) + b with f = log(1/(s + </a:t>
+            </a:r>
+            <a:r>
+              <a:rPr sz="1400" b="0" dirty="0" err="1">
+                <a:solidFill>
+                  <a:srgbClr val="212121"/>
+                </a:solidFill>
+                <a:latin typeface="Calibri"/>
+              </a:rPr>
+              <a:t>ε</a:t>
+            </a:r>
+            <a:r>
+              <a:rPr sz="1400" b="0" dirty="0">
+                <a:solidFill>
+                  <a:srgbClr val="212121"/>
+                </a:solidFill>
+                <a:latin typeface="Calibri"/>
+              </a:rPr>
+              <a:t>) − C).  Exponentiating: </a:t>
+            </a:r>
+            <a:r>
+              <a:rPr sz="1400" b="1" dirty="0" err="1">
+                <a:solidFill>
+                  <a:srgbClr val="212121"/>
+                </a:solidFill>
+                <a:latin typeface="Calibri"/>
+              </a:rPr>
+              <a:t>ρ</a:t>
+            </a:r>
+            <a:r>
+              <a:rPr sz="1400" b="1" dirty="0">
+                <a:solidFill>
+                  <a:srgbClr val="212121"/>
+                </a:solidFill>
+                <a:latin typeface="Calibri"/>
+              </a:rPr>
+              <a:t> ∝ [1/(s + </a:t>
+            </a:r>
+            <a:r>
+              <a:rPr sz="1400" b="1" dirty="0" err="1">
+                <a:solidFill>
+                  <a:srgbClr val="212121"/>
+                </a:solidFill>
+                <a:latin typeface="Calibri"/>
+              </a:rPr>
+              <a:t>ε</a:t>
+            </a:r>
+            <a:r>
+              <a:rPr sz="1400" b="1" dirty="0">
+                <a:solidFill>
+                  <a:srgbClr val="212121"/>
+                </a:solidFill>
+                <a:latin typeface="Calibri"/>
+              </a:rPr>
+              <a:t>) − C]ᵃ = [C(s_c − s)/(s + </a:t>
+            </a:r>
+            <a:r>
+              <a:rPr sz="1400" b="1" dirty="0" err="1">
+                <a:solidFill>
+                  <a:srgbClr val="212121"/>
+                </a:solidFill>
+                <a:latin typeface="Calibri"/>
+              </a:rPr>
+              <a:t>ε</a:t>
+            </a:r>
+            <a:r>
+              <a:rPr sz="1400" b="1" dirty="0">
+                <a:solidFill>
+                  <a:srgbClr val="212121"/>
+                </a:solidFill>
+                <a:latin typeface="Calibri"/>
+              </a:rPr>
+              <a:t>)]ᵃ</a:t>
+            </a:r>
+            <a:r>
+              <a:rPr sz="1400" b="0" dirty="0">
+                <a:solidFill>
+                  <a:srgbClr val="212121"/>
+                </a:solidFill>
+                <a:latin typeface="Calibri"/>
+              </a:rPr>
+              <a:t> with </a:t>
+            </a:r>
+            <a:r>
+              <a:rPr sz="1400" b="1" dirty="0">
+                <a:solidFill>
+                  <a:srgbClr val="212121"/>
+                </a:solidFill>
+                <a:latin typeface="Calibri"/>
+              </a:rPr>
+              <a:t>s_c = 1/C − </a:t>
+            </a:r>
+            <a:r>
+              <a:rPr sz="1400" b="1" dirty="0" err="1">
+                <a:solidFill>
+                  <a:srgbClr val="212121"/>
+                </a:solidFill>
+                <a:latin typeface="Calibri"/>
+              </a:rPr>
+              <a:t>ε</a:t>
+            </a:r>
+            <a:endParaRPr sz="1400" b="1" dirty="0">
+              <a:solidFill>
+                <a:srgbClr val="212121"/>
+              </a:solidFill>
+              <a:latin typeface="Calibri"/>
+            </a:endParaRPr>
+          </a:p>
+          <a:p>
+            <a:pPr marL="228600" indent="-228600">
+              <a:spcAft>
+                <a:spcPts val="800"/>
+              </a:spcAft>
+              <a:buChar char="•"/>
+            </a:pPr>
+            <a:r>
+              <a:rPr sz="1400" b="0" dirty="0">
+                <a:solidFill>
+                  <a:srgbClr val="212121"/>
+                </a:solidFill>
+                <a:latin typeface="Calibri"/>
+              </a:rPr>
+              <a:t>So the search hands over a bounded form with tied exponents, m = k = a.  The likelihood stage then frees m from k (8 of 8 cells prefer it)</a:t>
+            </a:r>
+          </a:p>
+          <a:p>
+            <a:pPr marL="228600" indent="-228600">
+              <a:spcAft>
+                <a:spcPts val="800"/>
+              </a:spcAft>
+              <a:buChar char="•"/>
+            </a:pPr>
+            <a:r>
+              <a:rPr sz="1400" b="0" dirty="0">
+                <a:solidFill>
+                  <a:srgbClr val="212121"/>
+                </a:solidFill>
+                <a:latin typeface="Calibri"/>
+              </a:rPr>
+              <a:t>Complexity 9 still lowers the misfit, but only by promoting a family the likelihood had already rejected. No new family appears, and the complexity-8 knee is unchanged</a:t>
+            </a:r>
+          </a:p>
+        </p:txBody>
+      </p:sp>
+    </p:spTree>
+  </p:cSld>
+  <p:clrMapOvr>
+    <a:masterClrMapping/>
+  </p:clrMapOvr>
+</p:sld>
+</file>
+
+<file path=ppt/slides/slide9.xml><?xml version="1.0" encoding="utf-8"?>
+<p:sld xmlns:a="http://schemas.openxmlformats.org/drawingml/2006/main" xmlns:r="http://schemas.openxmlformats.org/officeDocument/2006/relationships" xmlns:p="http://schemas.openxmlformats.org/presentationml/2006/main">
+  <p:cSld>
+    <p:spTree>
+      <p:nvGrpSpPr>
+        <p:cNvPr id="1" name=""/>
+        <p:cNvGrpSpPr/>
+        <p:nvPr/>
+      </p:nvGrpSpPr>
+      <p:grpSpPr>
+        <a:xfrm>
+          <a:off x="0" y="0"/>
+          <a:ext cx="0" cy="0"/>
+          <a:chOff x="0" y="0"/>
+          <a:chExt cx="0" cy="0"/>
+        </a:xfrm>
+      </p:grpSpPr>
+      <p:sp>
+        <p:nvSpPr>
+          <p:cNvPr id="2" name="TextBox 1"/>
+          <p:cNvSpPr txBox="1"/>
+          <p:nvPr/>
+        </p:nvSpPr>
+        <p:spPr>
+          <a:xfrm>
+            <a:off x="548640" y="292608"/>
+            <a:ext cx="11091672" cy="685800"/>
+          </a:xfrm>
+          <a:prstGeom prst="rect">
+            <a:avLst/>
+          </a:prstGeom>
+          <a:noFill/>
+        </p:spPr>
+        <p:txBody>
+          <a:bodyPr wrap="square" lIns="0" tIns="0" rIns="0" bIns="0">
+            <a:spAutoFit/>
+          </a:bodyPr>
+          <a:lstStyle/>
+          <a:p>
+            <a:r>
+              <a:rPr sz="3000" b="1">
+                <a:solidFill>
+                  <a:srgbClr val="1E2761"/>
+                </a:solidFill>
+                <a:latin typeface="Calibri"/>
+              </a:rPr>
+              <a:t>Performance: one cell, three candidate laws</a:t>
+            </a:r>
+          </a:p>
+        </p:txBody>
+      </p:sp>
+      <p:sp>
+        <p:nvSpPr>
+          <p:cNvPr id="4" name="TextBox 3"/>
+          <p:cNvSpPr txBox="1"/>
+          <p:nvPr/>
+        </p:nvSpPr>
+        <p:spPr>
+          <a:xfrm>
+            <a:off x="7086600" y="1280160"/>
+            <a:ext cx="4572000" cy="4572000"/>
+          </a:xfrm>
+          <a:prstGeom prst="rect">
+            <a:avLst/>
+          </a:prstGeom>
+          <a:noFill/>
+        </p:spPr>
+        <p:txBody>
+          <a:bodyPr wrap="square" lIns="0" tIns="0" rIns="0" bIns="0">
+            <a:spAutoFit/>
+          </a:bodyPr>
+          <a:lstStyle/>
+          <a:p>
+            <a:pPr>
+              <a:spcAft>
+                <a:spcPts val="600"/>
+              </a:spcAft>
+            </a:pPr>
+            <a:r>
+              <a:rPr sz="1600" b="1">
+                <a:solidFill>
+                  <a:srgbClr val="1E2761"/>
+                </a:solidFill>
+                <a:latin typeface="Calibri"/>
+              </a:rPr>
+              <a:t>The largest cell, 6,706 events, five decades of s</a:t>
+            </a:r>
+          </a:p>
+          <a:p>
+            <a:pPr marL="228600" indent="-228600">
+              <a:spcAft>
+                <a:spcPts val="800"/>
+              </a:spcAft>
+              <a:buChar char="•"/>
+            </a:pPr>
+            <a:r>
+              <a:rPr sz="1400" b="0">
+                <a:solidFill>
+                  <a:srgbClr val="212121"/>
+                </a:solidFill>
+                <a:latin typeface="Calibri"/>
+              </a:rPr>
+              <a:t>Black: measured density. </a:t>
+            </a:r>
+            <a:r>
+              <a:rPr sz="1400" b="1">
+                <a:solidFill>
+                  <a:srgbClr val="212121"/>
+                </a:solidFill>
+                <a:latin typeface="Calibri"/>
+              </a:rPr>
+              <a:t>Red: ceiling law</a:t>
+            </a:r>
+            <a:r>
+              <a:rPr sz="1400" b="0">
+                <a:solidFill>
+                  <a:srgbClr val="212121"/>
+                </a:solidFill>
+                <a:latin typeface="Calibri"/>
+              </a:rPr>
+              <a:t>. Blue dashed: best truncated power law (TPL). Green dotted: best lognormal</a:t>
+            </a:r>
+          </a:p>
+          <a:p>
+            <a:pPr marL="228600" indent="-228600">
+              <a:spcAft>
+                <a:spcPts val="800"/>
+              </a:spcAft>
+              <a:buChar char="•"/>
+            </a:pPr>
+            <a:r>
+              <a:rPr sz="1400" b="0">
+                <a:solidFill>
+                  <a:srgbClr val="212121"/>
+                </a:solidFill>
+                <a:latin typeface="Calibri"/>
+              </a:rPr>
+              <a:t>All three are maximum-likelihood fits of proper densities on the same events</a:t>
+            </a:r>
+          </a:p>
+          <a:p>
+            <a:pPr marL="228600" indent="-228600">
+              <a:spcAft>
+                <a:spcPts val="800"/>
+              </a:spcAft>
+              <a:buChar char="•"/>
+            </a:pPr>
+            <a:r>
+              <a:rPr sz="1400" b="0">
+                <a:solidFill>
+                  <a:srgbClr val="212121"/>
+                </a:solidFill>
+                <a:latin typeface="Calibri"/>
+              </a:rPr>
+              <a:t>Only the ceiling law gets </a:t>
+            </a:r>
+            <a:r>
+              <a:rPr sz="1400" b="1">
+                <a:solidFill>
+                  <a:srgbClr val="212121"/>
+                </a:solidFill>
+                <a:latin typeface="Calibri"/>
+              </a:rPr>
+              <a:t>both ends</a:t>
+            </a:r>
+            <a:r>
+              <a:rPr sz="1400" b="0">
+                <a:solidFill>
+                  <a:srgbClr val="212121"/>
+                </a:solidFill>
+                <a:latin typeface="Calibri"/>
+              </a:rPr>
+              <a:t>: the flattening below 3 × 10⁻⁵ and the stop at the dotted line (s_c)</a:t>
+            </a:r>
+          </a:p>
+          <a:p>
+            <a:pPr marL="228600" indent="-228600">
+              <a:spcAft>
+                <a:spcPts val="800"/>
+              </a:spcAft>
+              <a:buChar char="•"/>
+            </a:pPr>
+            <a:r>
+              <a:rPr sz="1400" b="0">
+                <a:solidFill>
+                  <a:srgbClr val="212121"/>
+                </a:solidFill>
+                <a:latin typeface="Calibri"/>
+              </a:rPr>
+              <a:t>The TPL tail decays too softly and overshoots</a:t>
+            </a:r>
+          </a:p>
+          <a:p>
+            <a:pPr marL="228600" indent="-228600">
+              <a:spcAft>
+                <a:spcPts val="800"/>
+              </a:spcAft>
+              <a:buChar char="•"/>
+            </a:pPr>
+            <a:r>
+              <a:rPr sz="1400" b="0">
+                <a:solidFill>
+                  <a:srgbClr val="212121"/>
+                </a:solidFill>
+                <a:latin typeface="Calibri"/>
+              </a:rPr>
+              <a:t>Full range: ceiling law over TPL by </a:t>
+            </a:r>
+            <a:r>
+              <a:rPr sz="1400" b="1">
+                <a:solidFill>
+                  <a:srgbClr val="212121"/>
+                </a:solidFill>
+                <a:latin typeface="Calibri"/>
+              </a:rPr>
+              <a:t>ΔAIC 200 to 345</a:t>
+            </a:r>
+          </a:p>
+        </p:txBody>
+      </p:sp>
+      <p:pic>
+        <p:nvPicPr>
+          <p:cNvPr id="5" name="Picture 4" descr="fig01_size_law.png"/>
+          <p:cNvPicPr>
+            <a:picLocks noChangeAspect="1"/>
+          </p:cNvPicPr>
+          <p:nvPr/>
+        </p:nvPicPr>
+        <p:blipFill>
+          <a:blip r:embed="rId3"/>
+          <a:stretch>
+            <a:fillRect/>
+          </a:stretch>
+        </p:blipFill>
+        <p:spPr>
+          <a:xfrm>
+            <a:off x="338328" y="978408"/>
+            <a:ext cx="6748272" cy="4873752"/>
+          </a:xfrm>
+          <a:prstGeom prst="rect">
+            <a:avLst/>
+          </a:prstGeom>
+        </p:spPr>
+      </p:pic>
     </p:spTree>
   </p:cSld>
   <p:clrMapOvr>
@@ -4837,4 +7263,319 @@
   </a:objectDefaults>
   <a:extraClrSchemeLst/>
 </a:theme>
+</file>
+
+<file path=ppt/theme/theme2.xml><?xml version="1.0" encoding="utf-8"?>
+<a:theme xmlns:a="http://schemas.openxmlformats.org/drawingml/2006/main" name="Office Theme">
+  <a:themeElements>
+    <a:clrScheme name="Office">
+      <a:dk1>
+        <a:sysClr val="windowText" lastClr="000000"/>
+      </a:dk1>
+      <a:lt1>
+        <a:sysClr val="window" lastClr="FFFFFF"/>
+      </a:lt1>
+      <a:dk2>
+        <a:srgbClr val="0E2841"/>
+      </a:dk2>
+      <a:lt2>
+        <a:srgbClr val="E8E8E8"/>
+      </a:lt2>
+      <a:accent1>
+        <a:srgbClr val="156082"/>
+      </a:accent1>
+      <a:accent2>
+        <a:srgbClr val="E97132"/>
+      </a:accent2>
+      <a:accent3>
+        <a:srgbClr val="196B24"/>
+      </a:accent3>
+      <a:accent4>
+        <a:srgbClr val="0F9ED5"/>
+      </a:accent4>
+      <a:accent5>
+        <a:srgbClr val="A02B93"/>
+      </a:accent5>
+      <a:accent6>
+        <a:srgbClr val="4EA72E"/>
+      </a:accent6>
+      <a:hlink>
+        <a:srgbClr val="467886"/>
+      </a:hlink>
+      <a:folHlink>
+        <a:srgbClr val="96607D"/>
+      </a:folHlink>
+    </a:clrScheme>
+    <a:fontScheme name="Office">
+      <a:majorFont>
+        <a:latin typeface="Aptos Display" panose="02110004020202020204"/>
+        <a:ea typeface=""/>
+        <a:cs typeface=""/>
+        <a:font script="Jpan" typeface="游ゴシック Light"/>
+        <a:font script="Hang" typeface="맑은 고딕"/>
+        <a:font script="Hans" typeface="等线 Light"/>
+        <a:font script="Hant" typeface="新細明體"/>
+        <a:font script="Arab" typeface="Times New Roman"/>
+        <a:font script="Hebr" typeface="Times New Roman"/>
+        <a:font script="Thai" typeface="Angsana New"/>
+        <a:font script="Ethi" typeface="Nyala"/>
+        <a:font script="Beng" typeface="Vrinda"/>
+        <a:font script="Gujr" typeface="Shruti"/>
+        <a:font script="Khmr" typeface="MoolBoran"/>
+        <a:font script="Knda" typeface="Tunga"/>
+        <a:font script="Guru" typeface="Raavi"/>
+        <a:font script="Cans" typeface="Euphemia"/>
+        <a:font script="Cher" typeface="Plantagenet Cherokee"/>
+        <a:font script="Yiii" typeface="Microsoft Yi Baiti"/>
+        <a:font script="Tibt" typeface="Microsoft Himalaya"/>
+        <a:font script="Thaa" typeface="MV Boli"/>
+        <a:font script="Deva" typeface="Mangal"/>
+        <a:font script="Telu" typeface="Gautami"/>
+        <a:font script="Taml" typeface="Latha"/>
+        <a:font script="Syrc" typeface="Estrangelo Edessa"/>
+        <a:font script="Orya" typeface="Kalinga"/>
+        <a:font script="Mlym" typeface="Kartika"/>
+        <a:font script="Laoo" typeface="DokChampa"/>
+        <a:font script="Sinh" typeface="Iskoola Pota"/>
+        <a:font script="Mong" typeface="Mongolian Baiti"/>
+        <a:font script="Viet" typeface="Times New Roman"/>
+        <a:font script="Uigh" typeface="Microsoft Uighur"/>
+        <a:font script="Geor" typeface="Sylfaen"/>
+        <a:font script="Armn" typeface="Arial"/>
+        <a:font script="Bugi" typeface="Leelawadee UI"/>
+        <a:font script="Bopo" typeface="Microsoft JhengHei"/>
+        <a:font script="Java" typeface="Javanese Text"/>
+        <a:font script="Lisu" typeface="Segoe UI"/>
+        <a:font script="Mymr" typeface="Myanmar Text"/>
+        <a:font script="Nkoo" typeface="Ebrima"/>
+        <a:font script="Olck" typeface="Nirmala UI"/>
+        <a:font script="Osma" typeface="Ebrima"/>
+        <a:font script="Phag" typeface="Phagspa"/>
+        <a:font script="Syrn" typeface="Estrangelo Edessa"/>
+        <a:font script="Syrj" typeface="Estrangelo Edessa"/>
+        <a:font script="Syre" typeface="Estrangelo Edessa"/>
+        <a:font script="Sora" typeface="Nirmala UI"/>
+        <a:font script="Tale" typeface="Microsoft Tai Le"/>
+        <a:font script="Talu" typeface="Microsoft New Tai Lue"/>
+        <a:font script="Tfng" typeface="Ebrima"/>
+      </a:majorFont>
+      <a:minorFont>
+        <a:latin typeface="Aptos" panose="02110004020202020204"/>
+        <a:ea typeface=""/>
+        <a:cs typeface=""/>
+        <a:font script="Jpan" typeface="游ゴシック"/>
+        <a:font script="Hang" typeface="맑은 고딕"/>
+        <a:font script="Hans" typeface="等线"/>
+        <a:font script="Hant" typeface="新細明體"/>
+        <a:font script="Arab" typeface="Arial"/>
+        <a:font script="Hebr" typeface="Arial"/>
+        <a:font script="Thai" typeface="Cordia New"/>
+        <a:font script="Ethi" typeface="Nyala"/>
+        <a:font script="Beng" typeface="Vrinda"/>
+        <a:font script="Gujr" typeface="Shruti"/>
+        <a:font script="Khmr" typeface="DaunPenh"/>
+        <a:font script="Knda" typeface="Tunga"/>
+        <a:font script="Guru" typeface="Raavi"/>
+        <a:font script="Cans" typeface="Euphemia"/>
+        <a:font script="Cher" typeface="Plantagenet Cherokee"/>
+        <a:font script="Yiii" typeface="Microsoft Yi Baiti"/>
+        <a:font script="Tibt" typeface="Microsoft Himalaya"/>
+        <a:font script="Thaa" typeface="MV Boli"/>
+        <a:font script="Deva" typeface="Mangal"/>
+        <a:font script="Telu" typeface="Gautami"/>
+        <a:font script="Taml" typeface="Latha"/>
+        <a:font script="Syrc" typeface="Estrangelo Edessa"/>
+        <a:font script="Orya" typeface="Kalinga"/>
+        <a:font script="Mlym" typeface="Kartika"/>
+        <a:font script="Laoo" typeface="DokChampa"/>
+        <a:font script="Sinh" typeface="Iskoola Pota"/>
+        <a:font script="Mong" typeface="Mongolian Baiti"/>
+        <a:font script="Viet" typeface="Arial"/>
+        <a:font script="Uigh" typeface="Microsoft Uighur"/>
+        <a:font script="Geor" typeface="Sylfaen"/>
+        <a:font script="Armn" typeface="Arial"/>
+        <a:font script="Bugi" typeface="Leelawadee UI"/>
+        <a:font script="Bopo" typeface="Microsoft JhengHei"/>
+        <a:font script="Java" typeface="Javanese Text"/>
+        <a:font script="Lisu" typeface="Segoe UI"/>
+        <a:font script="Mymr" typeface="Myanmar Text"/>
+        <a:font script="Nkoo" typeface="Ebrima"/>
+        <a:font script="Olck" typeface="Nirmala UI"/>
+        <a:font script="Osma" typeface="Ebrima"/>
+        <a:font script="Phag" typeface="Phagspa"/>
+        <a:font script="Syrn" typeface="Estrangelo Edessa"/>
+        <a:font script="Syrj" typeface="Estrangelo Edessa"/>
+        <a:font script="Syre" typeface="Estrangelo Edessa"/>
+        <a:font script="Sora" typeface="Nirmala UI"/>
+        <a:font script="Tale" typeface="Microsoft Tai Le"/>
+        <a:font script="Talu" typeface="Microsoft New Tai Lue"/>
+        <a:font script="Tfng" typeface="Ebrima"/>
+      </a:minorFont>
+    </a:fontScheme>
+    <a:fmtScheme name="Office">
+      <a:fillStyleLst>
+        <a:solidFill>
+          <a:schemeClr val="phClr"/>
+        </a:solidFill>
+        <a:gradFill rotWithShape="1">
+          <a:gsLst>
+            <a:gs pos="0">
+              <a:schemeClr val="phClr">
+                <a:lumMod val="110000"/>
+                <a:satMod val="105000"/>
+                <a:tint val="67000"/>
+              </a:schemeClr>
+            </a:gs>
+            <a:gs pos="50000">
+              <a:schemeClr val="phClr">
+                <a:lumMod val="105000"/>
+                <a:satMod val="103000"/>
+                <a:tint val="73000"/>
+              </a:schemeClr>
+            </a:gs>
+            <a:gs pos="100000">
+              <a:schemeClr val="phClr">
+                <a:lumMod val="105000"/>
+                <a:satMod val="109000"/>
+                <a:tint val="81000"/>
+              </a:schemeClr>
+            </a:gs>
+          </a:gsLst>
+          <a:lin ang="5400000" scaled="0"/>
+        </a:gradFill>
+        <a:gradFill rotWithShape="1">
+          <a:gsLst>
+            <a:gs pos="0">
+              <a:schemeClr val="phClr">
+                <a:satMod val="103000"/>
+                <a:lumMod val="102000"/>
+                <a:tint val="94000"/>
+              </a:schemeClr>
+            </a:gs>
+            <a:gs pos="50000">
+              <a:schemeClr val="phClr">
+                <a:satMod val="110000"/>
+                <a:lumMod val="100000"/>
+                <a:shade val="100000"/>
+              </a:schemeClr>
+            </a:gs>
+            <a:gs pos="100000">
+              <a:schemeClr val="phClr">
+                <a:lumMod val="99000"/>
+                <a:satMod val="120000"/>
+                <a:shade val="78000"/>
+              </a:schemeClr>
+            </a:gs>
+          </a:gsLst>
+          <a:lin ang="5400000" scaled="0"/>
+        </a:gradFill>
+      </a:fillStyleLst>
+      <a:lnStyleLst>
+        <a:ln w="12700" cap="flat" cmpd="sng" algn="ctr">
+          <a:solidFill>
+            <a:schemeClr val="phClr"/>
+          </a:solidFill>
+          <a:prstDash val="solid"/>
+          <a:miter lim="800000"/>
+        </a:ln>
+        <a:ln w="19050" cap="flat" cmpd="sng" algn="ctr">
+          <a:solidFill>
+            <a:schemeClr val="phClr"/>
+          </a:solidFill>
+          <a:prstDash val="solid"/>
+          <a:miter lim="800000"/>
+        </a:ln>
+        <a:ln w="25400" cap="flat" cmpd="sng" algn="ctr">
+          <a:solidFill>
+            <a:schemeClr val="phClr"/>
+          </a:solidFill>
+          <a:prstDash val="solid"/>
+          <a:miter lim="800000"/>
+        </a:ln>
+      </a:lnStyleLst>
+      <a:effectStyleLst>
+        <a:effectStyle>
+          <a:effectLst/>
+        </a:effectStyle>
+        <a:effectStyle>
+          <a:effectLst/>
+        </a:effectStyle>
+        <a:effectStyle>
+          <a:effectLst>
+            <a:outerShdw blurRad="57150" dist="19050" dir="5400000" algn="ctr" rotWithShape="0">
+              <a:srgbClr val="000000">
+                <a:alpha val="63000"/>
+              </a:srgbClr>
+            </a:outerShdw>
+          </a:effectLst>
+        </a:effectStyle>
+      </a:effectStyleLst>
+      <a:bgFillStyleLst>
+        <a:solidFill>
+          <a:schemeClr val="phClr"/>
+        </a:solidFill>
+        <a:solidFill>
+          <a:schemeClr val="phClr">
+            <a:tint val="95000"/>
+            <a:satMod val="170000"/>
+          </a:schemeClr>
+        </a:solidFill>
+        <a:gradFill rotWithShape="1">
+          <a:gsLst>
+            <a:gs pos="0">
+              <a:schemeClr val="phClr">
+                <a:tint val="93000"/>
+                <a:satMod val="150000"/>
+                <a:shade val="98000"/>
+                <a:lumMod val="102000"/>
+              </a:schemeClr>
+            </a:gs>
+            <a:gs pos="50000">
+              <a:schemeClr val="phClr">
+                <a:tint val="98000"/>
+                <a:satMod val="130000"/>
+                <a:shade val="90000"/>
+                <a:lumMod val="103000"/>
+              </a:schemeClr>
+            </a:gs>
+            <a:gs pos="100000">
+              <a:schemeClr val="phClr">
+                <a:shade val="63000"/>
+                <a:satMod val="120000"/>
+              </a:schemeClr>
+            </a:gs>
+          </a:gsLst>
+          <a:lin ang="5400000" scaled="0"/>
+        </a:gradFill>
+      </a:bgFillStyleLst>
+    </a:fmtScheme>
+  </a:themeElements>
+  <a:objectDefaults>
+    <a:lnDef>
+      <a:spPr/>
+      <a:bodyPr/>
+      <a:lstStyle/>
+      <a:style>
+        <a:lnRef idx="2">
+          <a:schemeClr val="accent1"/>
+        </a:lnRef>
+        <a:fillRef idx="0">
+          <a:schemeClr val="accent1"/>
+        </a:fillRef>
+        <a:effectRef idx="1">
+          <a:schemeClr val="accent1"/>
+        </a:effectRef>
+        <a:fontRef idx="minor">
+          <a:schemeClr val="tx1"/>
+        </a:fontRef>
+      </a:style>
+    </a:lnDef>
+  </a:objectDefaults>
+  <a:extraClrSchemeLst/>
+  <a:extLst>
+    <a:ext uri="{05A4C25C-085E-4340-85A3-A5531E510DB2}">
+      <thm15:themeFamily xmlns:thm15="http://schemas.microsoft.com/office/thememl/2012/main" name="Office Theme" id="{2E142A2C-CD16-42D6-873A-C26D2A0506FA}" vid="{1BDDFF52-6CD6-40A5-AB3C-68EB2F1E4D0A}"/>
+    </a:ext>
+  </a:extLst>
+</a:theme>
 </file>
</xml_diff>